<commit_message>
Verify and remove benchmarch performance
</commit_message>
<xml_diff>
--- a/Documents/Final_Presentation.pptx
+++ b/Documents/Final_Presentation.pptx
@@ -5,7 +5,7 @@
     <p:sldMasterId id="2147483648" r:id="rId1"/>
   </p:sldMasterIdLst>
   <p:notesMasterIdLst>
-    <p:notesMasterId r:id="rId20"/>
+    <p:notesMasterId r:id="rId15"/>
   </p:notesMasterIdLst>
   <p:sldIdLst>
     <p:sldId id="256" r:id="rId2"/>
@@ -18,11 +18,9 @@
     <p:sldId id="263" r:id="rId9"/>
     <p:sldId id="264" r:id="rId10"/>
     <p:sldId id="265" r:id="rId11"/>
-    <p:sldId id="269" r:id="rId15"/>
-    <p:sldId id="270" r:id="rId16"/>
-    <p:sldId id="271" r:id="rId17"/>
-    <p:sldId id="272" r:id="rId18"/>
-    <p:sldId id="273" r:id="rId19"/>
+    <p:sldId id="271" r:id="rId12"/>
+    <p:sldId id="272" r:id="rId13"/>
+    <p:sldId id="273" r:id="rId14"/>
   </p:sldIdLst>
   <p:sldSz cx="9144000" cy="5143500" type="screen16x9"/>
   <p:notesSz cx="5143500" cy="9144000"/>
@@ -732,10 +730,10 @@
           <a:p>
             <a:r>
               <a:rPr lang="en-US" dirty="0"/>
-              <a:t>This slide maps each of our 4 key challenges to concrete POC evidence. Schema Rigidity: adding SAT_Taxpayer_RiskLevel requires zero modifications to existing objects, detailed in our Implementation Scenarios document.
-Historical Tracking: Satellites maintain complete insert-only history, no destructive updates. Every change is a new row.
-ETL Control: 49-step pipeline in 120.9 seconds with per-step error isolation. If step 23 fails, steps 1-22 are preserved.
-Business Rules: Silver layer derived attributes like ComplianceScore are isolated from Bronze raw data.</a:t>
+              <a:t>This slide maps each of our 4 key challenges to concrete POC evidence. Schema Rigidity: adding SAT_Taxpayer_Contact requires zero modifications to existing 23 objects, as demonstrated in POC 1.
+Historical Tracking: Satellites maintain complete insert-only history with no destructive updates. Every change creates a new row with hash diff detection, demonstrated in POC 2.
+ETL Control: 49-step pipeline with per-step error isolation. If a step fails, all prior steps are preserved and only the failed step needs re-execution, demonstrated in POC 3.
+Business Rules: Silver layer derived attributes like ComplianceScore are isolated from Bronze raw data, demonstrated in POC 4.</a:t>
             </a:r>
           </a:p>
         </p:txBody>
@@ -776,7 +774,7 @@
 </p:notes>
 </file>
 
-<file path=ppt/notesSlides/notesSlide14.xml><?xml version="1.0" encoding="utf-8"?>
+<file path=ppt/notesSlides/notesSlide11.xml><?xml version="1.0" encoding="utf-8"?>
 <p:notes xmlns:a="http://schemas.openxmlformats.org/drawingml/2006/main" xmlns:r="http://schemas.openxmlformats.org/officeDocument/2006/relationships" xmlns:p="http://schemas.openxmlformats.org/presentationml/2006/main">
   <p:cSld>
     <p:spTree>
@@ -822,10 +820,8 @@
           <a:p>
             <a:r>
               <a:rPr lang="en-US" dirty="0"/>
-              <a:t>Three key discussion insights — all empirically verified on our GCP VM with SSMS screenshot evidence.
-First, Flexibility and Scalability: we created SAT_Taxpayer_RiskLevel with RiskLevel, RiskScore, and AssessmentDate columns. After loading 10 risk records, we verified all 23 existing Bronze objects had identical create_date and modify_date — proving zero impact on existing structures. The new Satellite was immediately queryable via LEFT JOIN with existing SAT_Taxpayer.
-Second, Materialized Views: we implemented vw_GoldMonthlyRevenue with SCHEMABINDING and a unique clustered index. Baseline complex query measured 73ms elapsed. With the NOEXPAND hint, it dropped to 34ms — a verified 2.1x speedup. This is less than the projected 4-6x because our POC has only 38,491 fact records; with production-scale millions of records, the improvement scales proportionally.
-Third, Early Arriving Facts: we tested with TAX-2026-EARLY. Hub was created at 06:40:14 with only the business key and zero Satellites. The Link to Declaration 99999 loaded at 06:40:15 — no Satellite data needed. Then 263 seconds later, the SAT_Taxpayer record arrived as a simple INSERT at 06:44:37. The 4-step chronological timeline proves DV2 handles this naturally — zero placeholders, zero UPDATEs, zero reconciliation. Full evidence in our Implementation Scenarios companion document.</a:t>
+              <a:t>Key achievements: complete 4-layer pipeline with 67 objects and 60 SSIS packages across 6 databases. Full and incremental loading validated through POC demonstrations. All 4 challenges addressed with implementation evidence. Performance benchmarking and scalability analysis identified as future work. Three companion documents provide full reproducibility.
+Three companion documents submitted: [32] Implementation Scenarios with verified SSMS screenshots for Flexibility (23/23 objects unchanged), Materialized Views (73ms to 34ms, 2.1x speedup), and Early Arriving Facts (263-second Hub-to-SAT delay, zero UPDATEs). [33] Performance Benchmarks Verification with reproducible SQL scripts and 14-point checklist. [34] Source Database Verification with 12-point checklist, all passing.</a:t>
             </a:r>
           </a:p>
         </p:txBody>
@@ -847,7 +843,7 @@
           <a:p>
             <a:fld id="{F7021451-1387-4CA6-816F-3879F97B5CBC}" type="slidenum">
               <a:rPr lang="en-US"/>
-              <a:t>14</a:t>
+              <a:t>11</a:t>
             </a:fld>
             <a:endParaRPr lang="en-US"/>
           </a:p>
@@ -866,7 +862,7 @@
 </p:notes>
 </file>
 
-<file path=ppt/notesSlides/notesSlide15.xml><?xml version="1.0" encoding="utf-8"?>
+<file path=ppt/notesSlides/notesSlide12.xml><?xml version="1.0" encoding="utf-8"?>
 <p:notes xmlns:a="http://schemas.openxmlformats.org/drawingml/2006/main" xmlns:r="http://schemas.openxmlformats.org/officeDocument/2006/relationships" xmlns:p="http://schemas.openxmlformats.org/presentationml/2006/main">
   <p:cSld>
     <p:spTree>
@@ -912,11 +908,9 @@
           <a:p>
             <a:r>
               <a:rPr lang="en-US" dirty="0"/>
-              <a:t>Four validity threats addressed. Internal: all 49 steps verified with row counts, hash key verification, zero data loss. Benchmarks averaged over 5 runs.
-External: simulated data verified with 12-point checklist in companion document. Real-world data would add complexity.
-Construct: ETL time, query latency, scalability, and POC assessment are standard DV2 metrics.
-Conclusion Validity: benchmarks report single-run timings without standard deviation or confidence intervals; GCP shared-core CPU may introduce timing variability.
-Conclusion: fully reproducible via Technical Implementation Guide and SQL scripts in appendices.</a:t>
+              <a:t>Three categories of future work. Short-term: integrate real GDT data, implement RBAC security, add Power BI dashboards. Medium-term: real-time CDC for near-real-time updates, Big Data scaling with columnstore indexes, implement indexed views.
+Long-term: multi-source integration with customs and business registration, machine learning for fraud detection, cloud migration to Azure SQL.
+Methodological priority: controlled experiment in production GDT environment with real data and user acceptance testing.</a:t>
             </a:r>
           </a:p>
         </p:txBody>
@@ -938,7 +932,7 @@
           <a:p>
             <a:fld id="{F7021451-1387-4CA6-816F-3879F97B5CBC}" type="slidenum">
               <a:rPr lang="en-US"/>
-              <a:t>15</a:t>
+              <a:t>12</a:t>
             </a:fld>
             <a:endParaRPr lang="en-US"/>
           </a:p>
@@ -957,7 +951,7 @@
 </p:notes>
 </file>
 
-<file path=ppt/notesSlides/notesSlide16.xml><?xml version="1.0" encoding="utf-8"?>
+<file path=ppt/notesSlides/notesSlide13.xml><?xml version="1.0" encoding="utf-8"?>
 <p:notes xmlns:a="http://schemas.openxmlformats.org/drawingml/2006/main" xmlns:r="http://schemas.openxmlformats.org/officeDocument/2006/relationships" xmlns:p="http://schemas.openxmlformats.org/presentationml/2006/main">
   <p:cSld>
     <p:spTree>
@@ -1003,8 +997,9 @@
           <a:p>
             <a:r>
               <a:rPr lang="en-US" dirty="0"/>
-              <a:t>Key achievements: complete 4-layer pipeline with 67 objects and 60 SSIS packages processing 336,677 records in 120.9 seconds. Gold queries 1.03x to 8.3x faster than raw Bronze. ETL scales linearly at approximately 2,200 records per second. All 4 challenges addressed with implementation evidence.
-Three companion documents submitted: [32] Implementation Scenarios with verified SSMS screenshots for Flexibility (23/23 objects unchanged), Materialized Views (73ms to 34ms, 2.1x speedup), and Early Arriving Facts (263-second Hub-to-SAT delay, zero UPDATEs). [33] Performance Benchmarks Verification with reproducible SQL scripts and 14-point checklist. [34] Source Database Verification with 12-point checklist, all passing.</a:t>
+              <a:t>Thank you for your attention. I am ready for questions.
+Key numbers: 67 objects, 60 SSIS packages, 49 ETL steps across 6 databases, 4 POC demonstrations validating all challenges, 12 source database verification checks all passed, 3 companion documents for full reproducibility.
+Companion documents submitted: [32] Implementation Scenarios (13 pages, 12 SSMS screenshots, verified results for Flexibility, Materialized Views, Early Arriving Facts), [33] Performance Benchmarks Verification (13 pages, reproducible SQL scripts, 14-point checklist), [34] Source Database Verification (8 pages, 12-point checklist). All SQL scripts and screenshots are independently reproducible on the GCP VM.</a:t>
             </a:r>
           </a:p>
         </p:txBody>
@@ -1026,185 +1021,7 @@
           <a:p>
             <a:fld id="{F7021451-1387-4CA6-816F-3879F97B5CBC}" type="slidenum">
               <a:rPr lang="en-US"/>
-              <a:t>16</a:t>
-            </a:fld>
-            <a:endParaRPr lang="en-US"/>
-          </a:p>
-        </p:txBody>
-      </p:sp>
-    </p:spTree>
-    <p:extLst>
-      <p:ext uri="{BB962C8B-B14F-4D97-AF65-F5344CB8AC3E}">
-        <p14:creationId xmlns:p14="http://schemas.microsoft.com/office/powerpoint/2010/main" val="1024086991"/>
-      </p:ext>
-    </p:extLst>
-  </p:cSld>
-  <p:clrMapOvr>
-    <a:masterClrMapping/>
-  </p:clrMapOvr>
-</p:notes>
-</file>
-
-<file path=ppt/notesSlides/notesSlide17.xml><?xml version="1.0" encoding="utf-8"?>
-<p:notes xmlns:a="http://schemas.openxmlformats.org/drawingml/2006/main" xmlns:r="http://schemas.openxmlformats.org/officeDocument/2006/relationships" xmlns:p="http://schemas.openxmlformats.org/presentationml/2006/main">
-  <p:cSld>
-    <p:spTree>
-      <p:nvGrpSpPr>
-        <p:cNvPr id="1" name=""/>
-        <p:cNvGrpSpPr/>
-        <p:nvPr/>
-      </p:nvGrpSpPr>
-      <p:grpSpPr>
-        <a:xfrm>
-          <a:off x="0" y="0"/>
-          <a:ext cx="0" cy="0"/>
-          <a:chOff x="0" y="0"/>
-          <a:chExt cx="0" cy="0"/>
-        </a:xfrm>
-      </p:grpSpPr>
-      <p:sp>
-        <p:nvSpPr>
-          <p:cNvPr id="2" name="Slide Image Placeholder 1"/>
-          <p:cNvSpPr>
-            <a:spLocks noGrp="1" noRot="1" noChangeAspect="1"/>
-          </p:cNvSpPr>
-          <p:nvPr>
-            <p:ph type="sldImg"/>
-          </p:nvPr>
-        </p:nvSpPr>
-        <p:spPr/>
-      </p:sp>
-      <p:sp>
-        <p:nvSpPr>
-          <p:cNvPr id="3" name="Notes Placeholder 2"/>
-          <p:cNvSpPr>
-            <a:spLocks noGrp="1"/>
-          </p:cNvSpPr>
-          <p:nvPr>
-            <p:ph type="body" idx="1"/>
-          </p:nvPr>
-        </p:nvSpPr>
-        <p:spPr/>
-        <p:txBody>
-          <a:bodyPr/>
-          <a:lstStyle/>
-          <a:p>
-            <a:r>
-              <a:rPr lang="en-US" dirty="0"/>
-              <a:t>Three categories of future work. Short-term: integrate real GDT data, implement RBAC security, add Power BI dashboards. Medium-term: real-time CDC for near-real-time updates, Big Data scaling with columnstore indexes, implement indexed views.
-Long-term: multi-source integration with customs and business registration, machine learning for fraud detection, cloud migration to Azure SQL.
-Methodological priority: controlled experiment in production GDT environment with real data and user acceptance testing.</a:t>
-            </a:r>
-          </a:p>
-        </p:txBody>
-      </p:sp>
-      <p:sp>
-        <p:nvSpPr>
-          <p:cNvPr id="4" name="Slide Number Placeholder 3"/>
-          <p:cNvSpPr>
-            <a:spLocks noGrp="1"/>
-          </p:cNvSpPr>
-          <p:nvPr>
-            <p:ph type="sldNum" sz="quarter" idx="10"/>
-          </p:nvPr>
-        </p:nvSpPr>
-        <p:spPr/>
-        <p:txBody>
-          <a:bodyPr/>
-          <a:lstStyle/>
-          <a:p>
-            <a:fld id="{F7021451-1387-4CA6-816F-3879F97B5CBC}" type="slidenum">
-              <a:rPr lang="en-US"/>
-              <a:t>17</a:t>
-            </a:fld>
-            <a:endParaRPr lang="en-US"/>
-          </a:p>
-        </p:txBody>
-      </p:sp>
-    </p:spTree>
-    <p:extLst>
-      <p:ext uri="{BB962C8B-B14F-4D97-AF65-F5344CB8AC3E}">
-        <p14:creationId xmlns:p14="http://schemas.microsoft.com/office/powerpoint/2010/main" val="1024086991"/>
-      </p:ext>
-    </p:extLst>
-  </p:cSld>
-  <p:clrMapOvr>
-    <a:masterClrMapping/>
-  </p:clrMapOvr>
-</p:notes>
-</file>
-
-<file path=ppt/notesSlides/notesSlide18.xml><?xml version="1.0" encoding="utf-8"?>
-<p:notes xmlns:a="http://schemas.openxmlformats.org/drawingml/2006/main" xmlns:r="http://schemas.openxmlformats.org/officeDocument/2006/relationships" xmlns:p="http://schemas.openxmlformats.org/presentationml/2006/main">
-  <p:cSld>
-    <p:spTree>
-      <p:nvGrpSpPr>
-        <p:cNvPr id="1" name=""/>
-        <p:cNvGrpSpPr/>
-        <p:nvPr/>
-      </p:nvGrpSpPr>
-      <p:grpSpPr>
-        <a:xfrm>
-          <a:off x="0" y="0"/>
-          <a:ext cx="0" cy="0"/>
-          <a:chOff x="0" y="0"/>
-          <a:chExt cx="0" cy="0"/>
-        </a:xfrm>
-      </p:grpSpPr>
-      <p:sp>
-        <p:nvSpPr>
-          <p:cNvPr id="2" name="Slide Image Placeholder 1"/>
-          <p:cNvSpPr>
-            <a:spLocks noGrp="1" noRot="1" noChangeAspect="1"/>
-          </p:cNvSpPr>
-          <p:nvPr>
-            <p:ph type="sldImg"/>
-          </p:nvPr>
-        </p:nvSpPr>
-        <p:spPr/>
-      </p:sp>
-      <p:sp>
-        <p:nvSpPr>
-          <p:cNvPr id="3" name="Notes Placeholder 2"/>
-          <p:cNvSpPr>
-            <a:spLocks noGrp="1"/>
-          </p:cNvSpPr>
-          <p:nvPr>
-            <p:ph type="body" idx="1"/>
-          </p:nvPr>
-        </p:nvSpPr>
-        <p:spPr/>
-        <p:txBody>
-          <a:bodyPr/>
-          <a:lstStyle/>
-          <a:p>
-            <a:r>
-              <a:rPr lang="en-US" dirty="0"/>
-              <a:t>Thank you for your attention. I am ready for questions.
-Key numbers: 67 objects, 60 SSIS packages, 49 ETL steps, 336,677 records in 120.9 seconds, Gold queries 1.03x-8.3x faster, linear scalability at 2,200 records/second, 12 verification checks all passed.
-Companion documents submitted: [32] Implementation Scenarios (13 pages, 12 SSMS screenshots, verified results for Flexibility, Materialized Views, Early Arriving Facts), [33] Performance Benchmarks Verification (13 pages, reproducible SQL scripts, 14-point checklist), [34] Source Database Verification (8 pages, 12-point checklist). All SQL scripts and screenshots are independently reproducible on the GCP VM.</a:t>
-            </a:r>
-          </a:p>
-        </p:txBody>
-      </p:sp>
-      <p:sp>
-        <p:nvSpPr>
-          <p:cNvPr id="4" name="Slide Number Placeholder 3"/>
-          <p:cNvSpPr>
-            <a:spLocks noGrp="1"/>
-          </p:cNvSpPr>
-          <p:nvPr>
-            <p:ph type="sldNum" sz="quarter" idx="10"/>
-          </p:nvPr>
-        </p:nvSpPr>
-        <p:spPr/>
-        <p:txBody>
-          <a:bodyPr/>
-          <a:lstStyle/>
-          <a:p>
-            <a:fld id="{F7021451-1387-4CA6-816F-3879F97B5CBC}" type="slidenum">
-              <a:rPr lang="en-US"/>
-              <a:t>18</a:t>
+              <a:t>13</a:t>
             </a:fld>
             <a:endParaRPr lang="en-US"/>
           </a:p>
@@ -1358,7 +1175,7 @@
               <a:rPr lang="en-US" dirty="0"/>
               <a:t>Cambodia's GDT is undergoing digital transformation with growing data volumes. Traditional approaches have limitations: Kimball's star schema is rigid — regulatory changes require costly schema modifications. Inmon's 3NF approach produces complex ETL and slow analytical queries due to many joins.
 We identified 4 key challenges: schema rigidity when regulations change, limited audit trails, monolithic ETL with no error recovery, and no separation of raw data from business rules.
-Data Vault 2.0 addresses all 4 challenges through its hub-satellite-link architecture. Our study has 6 objectives, including building the complete 4-layer pipeline, ETL control framework, performance benchmarks, and two companion documents for reproducibility and verification.</a:t>
+Data Vault 2.0 addresses all 4 challenges through its hub-satellite-link architecture. Our study has 6 objectives, including building the complete 4-layer pipeline, ETL control framework, POC evaluation, and two companion documents for reproducibility and verification.</a:t>
             </a:r>
           </a:p>
         </p:txBody>
@@ -1446,7 +1263,7 @@
             <a:r>
               <a:rPr lang="en-US" dirty="0"/>
               <a:t>The research gap is clear: most Data Vault 2.0 studies are theoretical or limited to specific domains. No published study provides an end-to-end DV2 + Medallion implementation for government tax administration.
-Our 5 contributions: C1 is the first complete 4-layer implementation with 67 objects and 60 SSIS packages. C2 provides integrated ETL control with batch and step-level logging. C3 delivers measurable performance benchmarks. C4 is POC evaluation addressing all 4 challenges with implementation evidence. C5 provides a reproducible Technical Implementation Guide.</a:t>
+Our 5 contributions: C1 is the first complete 4-layer implementation with 67 objects and 60 SSIS packages. C2 provides integrated ETL control with batch and step-level logging. C3 is POC evaluation addressing all 4 challenges with measurable before/after evidence on the Cambodia tax domain. C4 provides a reproducible Technical Implementation Guide for SSIS deployment. C5 provides Source Database Verification plus companion documents for full reproducibility.</a:t>
             </a:r>
           </a:p>
         </p:txBody>
@@ -1533,7 +1350,7 @@
           <a:p>
             <a:r>
               <a:rPr lang="en-US" dirty="0"/>
-              <a:t>Our theoretical foundation rests on three pillars. First, Linstedt and Olschimke's 2016 Data Vault 2.0 methodology, which defines the hub-satellite-link architecture, hash key generation using SHA-256, and insert-only loading patterns.
+              <a:t>Our theoretical foundation rests on three pillars. First, Linstedt and Olschimke's 2015 Data Vault 2.0 methodology, which defines the hub-satellite-link architecture, hash key generation using SHA-256, and insert-only loading patterns.
 Second, Armbrust et al.'s 2021 Medallion Architecture with Bronze, Silver, and Gold layers providing progressive data refinement. We adapted this for SQL Server by mapping Bronze to Raw Vault, Silver to Business Vault, and Gold to Star Schema.
 Third, Kimball's 34 ETL subsystems framework guides our control architecture. We combine this with DAMA data quality dimensions and watermark-based incremental loading using the MAX ModifiedDate pattern. Our contribution is integrating all three into a single framework with per-step error isolation.</a:t>
             </a:r>
@@ -1622,7 +1439,7 @@
           <a:p>
             <a:r>
               <a:rPr lang="en-US" dirty="0"/>
-              <a:t>This table compares 6 related studies. Yessad and Labiod in 2016 compared Inmon, Kimball, and Data Vault theoretically but had no implementation. Schafer et al. in 2020 implemented DV2 in healthcare but without Medallion Architecture. Giebler et al. in 2021 worked with big data on Hadoop. Vines in 2024 is the most recent using TPC-DS benchmarks.
+              <a:t>This table compares 4 key related studies plus our research. Yessad and Labiod in 2016 compared Inmon, Kimball, and Data Vault theoretically but had no implementation. Naamane and Jovanovic in 2016 provided empirical comparison with telecom data but without medallion architecture or a Gold layer. Vines in 2024 is the most recent, using TPC-DS benchmarks for performance evaluation but without domain-specific application. Singh in 2025 analyzed architectural resilience but remained theoretical with no hands-on implementation.
 Our study is the first to combine DV2 + Medallion + ETL Control + Performance Benchmarks in a government tax domain. The key gap: no published end-to-end DV2 + Medallion for government tax administration.</a:t>
             </a:r>
           </a:p>
@@ -1799,7 +1616,7 @@
           <a:p>
             <a:r>
               <a:rPr lang="en-US" dirty="0"/>
-              <a:t>Detailed object breakdown across 4 layers. Staging: 9 tables with full and incremental loading. Bronze: 9 Hubs for business keys, 10 Satellites for descriptive attributes with hash diff change detection, 5 Links for relationships.
+              <a:t>Detailed object breakdown across 4 layers. Staging: 9 tables with full and incremental loading. Bronze: 9 Hubs for business keys, 9 Satellites for descriptive attributes with hash diff change detection, 5 Links for relationships.
 Silver: 2 PIT tables for Point-In-Time lookups, 1 Bridge table, 3 Business Vault objects including ComplianceScore. Gold: 6 SCD Type 2 dimensions, 3 fact tables, 2 analytical views.
 Total: 67 objects across 4 layers, 49 automated steps orchestrated by ETL Control Framework.</a:t>
             </a:r>
@@ -1890,7 +1707,7 @@
               <a:rPr lang="en-US" dirty="0"/>
               <a:t>The source database TaxSystemDB contains 9 tables in 3 categories: 3 lookup tables for categories, structures, and activities; 3 reference tables for taxpayers, owners, and officers; and 3 transaction tables for monthly declarations, annual declarations, and payments.
 The data generator script 02_TransactionData.sql produces 1,002 taxpayers across 5 categories, 4 years of data from 2020 to 2023, with 99.8% filing coverage. Total records are 58,813.
-This data has been independently verified in our Source Database Verification companion document with a 12-point checklist: 10 foreign keys, 19 CHECK constraints, 37 indexes, zero orphan records across 7 relationships, zero NULLs on 8 critical columns, and unique TaxID verification.</a:t>
+This data has been independently verified in our Source Database Verification companion document with a 12-point checklist: 10 foreign keys, 19 CHECK constraints, 35 indexes, zero orphan records across 7 relationships, zero NULLs on 8 critical columns, and unique TaxID verification.</a:t>
             </a:r>
           </a:p>
         </p:txBody>
@@ -2744,7 +2561,7 @@
                   <a:srgbClr val="64748B"/>
                 </a:solidFill>
               </a:rPr>
-              <a:t>10 / 15</a:t>
+              <a:t>10 / 13</a:t>
             </a:r>
             <a:endParaRPr lang="en-US" sz="900" dirty="0"/>
           </a:p>
@@ -3513,1545 +3330,6 @@
 </file>
 
 <file path=ppt/slides/slide11.xml><?xml version="1.0" encoding="utf-8"?>
-<p:sld xmlns:a="http://schemas.openxmlformats.org/drawingml/2006/main" xmlns:r="http://schemas.openxmlformats.org/officeDocument/2006/relationships" xmlns:p="http://schemas.openxmlformats.org/presentationml/2006/main">
-  <p:cSld name="Slide 14">
-    <p:bg>
-      <p:bgPr>
-        <a:solidFill>
-          <a:srgbClr val="F7FAFA"/>
-        </a:solidFill>
-        <a:effectLst/>
-      </p:bgPr>
-    </p:bg>
-    <p:spTree>
-      <p:nvGrpSpPr>
-        <p:cNvPr id="1" name=""/>
-        <p:cNvGrpSpPr/>
-        <p:nvPr/>
-      </p:nvGrpSpPr>
-      <p:grpSpPr>
-        <a:xfrm>
-          <a:off x="0" y="0"/>
-          <a:ext cx="0" cy="0"/>
-          <a:chOff x="0" y="0"/>
-          <a:chExt cx="0" cy="0"/>
-        </a:xfrm>
-      </p:grpSpPr>
-      <p:sp>
-        <p:nvSpPr>
-          <p:cNvPr id="2" name="Shape 0"/>
-          <p:cNvSpPr/>
-          <p:nvPr/>
-        </p:nvSpPr>
-        <p:spPr>
-          <a:xfrm>
-            <a:off x="0" y="0"/>
-            <a:ext cx="54864" cy="5143500"/>
-          </a:xfrm>
-          <a:prstGeom prst="rect">
-            <a:avLst/>
-          </a:prstGeom>
-          <a:solidFill>
-            <a:srgbClr val="2A9D8F"/>
-          </a:solidFill>
-          <a:ln/>
-        </p:spPr>
-        <p:txBody>
-          <a:bodyPr/>
-          <a:lstStyle/>
-          <a:p>
-            <a:endParaRPr/>
-          </a:p>
-        </p:txBody>
-      </p:sp>
-      <p:sp>
-        <p:nvSpPr>
-          <p:cNvPr id="3" name="Text 1"/>
-          <p:cNvSpPr/>
-          <p:nvPr/>
-        </p:nvSpPr>
-        <p:spPr>
-          <a:xfrm>
-            <a:off x="8046720" y="4754880"/>
-            <a:ext cx="914400" cy="274320"/>
-          </a:xfrm>
-          <a:prstGeom prst="rect">
-            <a:avLst/>
-          </a:prstGeom>
-          <a:noFill/>
-          <a:ln/>
-        </p:spPr>
-        <p:txBody>
-          <a:bodyPr wrap="square" rtlCol="0" anchor="ctr"/>
-          <a:lstStyle/>
-          <a:p>
-            <a:pPr marL="0" indent="0" algn="r">
-              <a:buNone/>
-            </a:pPr>
-            <a:r>
-              <a:rPr lang="en-US" sz="900" dirty="0">
-                <a:solidFill>
-                  <a:srgbClr val="64748B"/>
-                </a:solidFill>
-              </a:rPr>
-              <a:t>11 / 15</a:t>
-            </a:r>
-            <a:endParaRPr lang="en-US" sz="900" dirty="0"/>
-          </a:p>
-        </p:txBody>
-      </p:sp>
-      <p:sp>
-        <p:nvSpPr>
-          <p:cNvPr id="4" name="Text 2"/>
-          <p:cNvSpPr/>
-          <p:nvPr/>
-        </p:nvSpPr>
-        <p:spPr>
-          <a:xfrm>
-            <a:off x="457200" y="182880"/>
-            <a:ext cx="8229600" cy="502920"/>
-          </a:xfrm>
-          <a:prstGeom prst="rect">
-            <a:avLst/>
-          </a:prstGeom>
-          <a:noFill/>
-          <a:ln/>
-        </p:spPr>
-        <p:txBody>
-          <a:bodyPr wrap="square" rtlCol="0" anchor="ctr"/>
-          <a:lstStyle/>
-          <a:p>
-            <a:pPr marL="0" indent="0">
-              <a:buNone/>
-            </a:pPr>
-            <a:r>
-              <a:rPr lang="en-US" sz="2200" b="1" dirty="0">
-                <a:solidFill>
-                  <a:srgbClr val="1B3A5C"/>
-                </a:solidFill>
-                <a:latin typeface="Georgia" pitchFamily="34" charset="0"/>
-                <a:ea typeface="Georgia" pitchFamily="34" charset="-122"/>
-                <a:cs typeface="Georgia" pitchFamily="34" charset="-120"/>
-              </a:rPr>
-              <a:t>Discussion — Key Insights</a:t>
-            </a:r>
-            <a:endParaRPr lang="en-US" sz="2200" dirty="0"/>
-          </a:p>
-        </p:txBody>
-      </p:sp>
-      <p:sp>
-        <p:nvSpPr>
-          <p:cNvPr id="5" name="Shape 3"/>
-          <p:cNvSpPr/>
-          <p:nvPr/>
-        </p:nvSpPr>
-        <p:spPr>
-          <a:xfrm>
-            <a:off x="457200" y="731520"/>
-            <a:ext cx="1097280" cy="36576"/>
-          </a:xfrm>
-          <a:prstGeom prst="rect">
-            <a:avLst/>
-          </a:prstGeom>
-          <a:solidFill>
-            <a:srgbClr val="2A9D8F"/>
-          </a:solidFill>
-          <a:ln/>
-        </p:spPr>
-        <p:txBody>
-          <a:bodyPr/>
-          <a:lstStyle/>
-          <a:p>
-            <a:endParaRPr/>
-          </a:p>
-        </p:txBody>
-      </p:sp>
-      <p:sp>
-        <p:nvSpPr>
-          <p:cNvPr id="6" name="Shape 4"/>
-          <p:cNvSpPr/>
-          <p:nvPr/>
-        </p:nvSpPr>
-        <p:spPr>
-          <a:xfrm>
-            <a:off x="274320" y="914400"/>
-            <a:ext cx="2834640" cy="3749040"/>
-          </a:xfrm>
-          <a:prstGeom prst="rect">
-            <a:avLst/>
-          </a:prstGeom>
-          <a:solidFill>
-            <a:srgbClr val="FFFFFF"/>
-          </a:solidFill>
-          <a:ln/>
-          <a:effectLst>
-            <a:outerShdw blurRad="50800" dist="25400" dir="8100000" algn="bl" rotWithShape="0">
-              <a:srgbClr val="000000">
-                <a:alpha val="10000"/>
-              </a:srgbClr>
-            </a:outerShdw>
-          </a:effectLst>
-        </p:spPr>
-        <p:txBody>
-          <a:bodyPr/>
-          <a:lstStyle/>
-          <a:p>
-            <a:endParaRPr/>
-          </a:p>
-        </p:txBody>
-      </p:sp>
-      <p:sp>
-        <p:nvSpPr>
-          <p:cNvPr id="7" name="Shape 5"/>
-          <p:cNvSpPr/>
-          <p:nvPr/>
-        </p:nvSpPr>
-        <p:spPr>
-          <a:xfrm>
-            <a:off x="274320" y="914400"/>
-            <a:ext cx="54864" cy="3749040"/>
-          </a:xfrm>
-          <a:prstGeom prst="rect">
-            <a:avLst/>
-          </a:prstGeom>
-          <a:solidFill>
-            <a:srgbClr val="2A9D8F"/>
-          </a:solidFill>
-          <a:ln/>
-        </p:spPr>
-        <p:txBody>
-          <a:bodyPr/>
-          <a:lstStyle/>
-          <a:p>
-            <a:endParaRPr/>
-          </a:p>
-        </p:txBody>
-      </p:sp>
-      <p:sp>
-        <p:nvSpPr>
-          <p:cNvPr id="8" name="Text 6"/>
-          <p:cNvSpPr/>
-          <p:nvPr/>
-        </p:nvSpPr>
-        <p:spPr>
-          <a:xfrm>
-            <a:off x="411480" y="960120"/>
-            <a:ext cx="2560320" cy="228600"/>
-          </a:xfrm>
-          <a:prstGeom prst="rect">
-            <a:avLst/>
-          </a:prstGeom>
-          <a:noFill/>
-          <a:ln/>
-        </p:spPr>
-        <p:txBody>
-          <a:bodyPr wrap="square" rtlCol="0" anchor="ctr"/>
-          <a:lstStyle/>
-          <a:p>
-            <a:pPr marL="0" indent="0">
-              <a:buNone/>
-            </a:pPr>
-            <a:r>
-              <a:rPr lang="en-US" sz="1100" b="1" dirty="0">
-                <a:solidFill>
-                  <a:srgbClr val="1B3A5C"/>
-                </a:solidFill>
-                <a:latin typeface="Georgia" pitchFamily="34" charset="0"/>
-                <a:ea typeface="Georgia" pitchFamily="34" charset="-122"/>
-                <a:cs typeface="Georgia" pitchFamily="34" charset="-120"/>
-              </a:rPr>
-              <a:t>5.2.5 Flexibility &amp; Scalability</a:t>
-            </a:r>
-            <a:endParaRPr lang="en-US" sz="1100" dirty="0"/>
-          </a:p>
-        </p:txBody>
-      </p:sp>
-      <p:sp>
-        <p:nvSpPr>
-          <p:cNvPr id="9" name="Text 7"/>
-          <p:cNvSpPr/>
-          <p:nvPr/>
-        </p:nvSpPr>
-        <p:spPr>
-          <a:xfrm>
-            <a:off x="411480" y="1280160"/>
-            <a:ext cx="2560320" cy="1645920"/>
-          </a:xfrm>
-          <a:prstGeom prst="rect">
-            <a:avLst/>
-          </a:prstGeom>
-          <a:noFill/>
-          <a:ln/>
-        </p:spPr>
-        <p:txBody>
-          <a:bodyPr wrap="square" rtlCol="0" anchor="ctr"/>
-          <a:lstStyle/>
-          <a:p>
-            <a:pPr marL="342900" indent="-342900">
-              <a:spcAft>
-                <a:spcPts val="500"/>
-              </a:spcAft>
-              <a:buSzPct val="100000"/>
-              <a:buChar char="•"/>
-            </a:pPr>
-            <a:r>
-              <a:rPr lang="en-US" sz="900" dirty="0">
-                <a:solidFill>
-                  <a:srgbClr val="1E293B"/>
-                </a:solidFill>
-              </a:rPr>
-              <a:t>New attributes → add Satellite only (no Hub/Link impact)</a:t>
-            </a:r>
-            <a:endParaRPr lang="en-US" sz="900" dirty="0"/>
-          </a:p>
-          <a:p>
-            <a:pPr marL="342900" indent="-342900">
-              <a:spcAft>
-                <a:spcPts val="500"/>
-              </a:spcAft>
-              <a:buSzPct val="100000"/>
-              <a:buChar char="•"/>
-            </a:pPr>
-            <a:r>
-              <a:rPr lang="en-US" sz="900" dirty="0">
-                <a:solidFill>
-                  <a:srgbClr val="1E293B"/>
-                </a:solidFill>
-              </a:rPr>
-              <a:t>New business rules → modify Silver layer only</a:t>
-            </a:r>
-            <a:endParaRPr lang="en-US" sz="900" dirty="0"/>
-          </a:p>
-          <a:p>
-            <a:pPr marL="342900" indent="-342900">
-              <a:spcAft>
-                <a:spcPts val="500"/>
-              </a:spcAft>
-              <a:buSzPct val="100000"/>
-              <a:buChar char="•"/>
-            </a:pPr>
-            <a:r>
-              <a:rPr lang="en-US" sz="900" dirty="0">
-                <a:solidFill>
-                  <a:srgbClr val="1E293B"/>
-                </a:solidFill>
-              </a:rPr>
-              <a:t>New reporting → add Gold dims/facts independently</a:t>
-            </a:r>
-            <a:endParaRPr lang="en-US" sz="900" dirty="0"/>
-          </a:p>
-          <a:p>
-            <a:pPr marL="342900" indent="-342900">
-              <a:spcAft>
-                <a:spcPts val="500"/>
-              </a:spcAft>
-              <a:buSzPct val="100000"/>
-              <a:buChar char="•"/>
-            </a:pPr>
-            <a:r>
-              <a:rPr lang="en-US" sz="900" b="1" dirty="0">
-                <a:solidFill>
-                  <a:srgbClr val="2A9D8F"/>
-                </a:solidFill>
-              </a:rPr>
-              <a:t>Verified: 23/23 objects UNCHANGED after adding SAT_Taxpayer_RiskLevel</a:t>
-            </a:r>
-            <a:endParaRPr lang="en-US" sz="900" dirty="0"/>
-          </a:p>
-        </p:txBody>
-      </p:sp>
-      <p:sp>
-        <p:nvSpPr>
-          <p:cNvPr id="10" name="Shape 8"/>
-          <p:cNvSpPr/>
-          <p:nvPr/>
-        </p:nvSpPr>
-        <p:spPr>
-          <a:xfrm>
-            <a:off x="411480" y="3931920"/>
-            <a:ext cx="2560320" cy="548640"/>
-          </a:xfrm>
-          <a:prstGeom prst="rect">
-            <a:avLst/>
-          </a:prstGeom>
-          <a:solidFill>
-            <a:srgbClr val="E8F4F2"/>
-          </a:solidFill>
-          <a:ln/>
-        </p:spPr>
-        <p:txBody>
-          <a:bodyPr/>
-          <a:lstStyle/>
-          <a:p>
-            <a:endParaRPr/>
-          </a:p>
-        </p:txBody>
-      </p:sp>
-      <p:sp>
-        <p:nvSpPr>
-          <p:cNvPr id="11" name="Text 9"/>
-          <p:cNvSpPr/>
-          <p:nvPr/>
-        </p:nvSpPr>
-        <p:spPr>
-          <a:xfrm>
-            <a:off x="502920" y="3931920"/>
-            <a:ext cx="2377440" cy="548640"/>
-          </a:xfrm>
-          <a:prstGeom prst="rect">
-            <a:avLst/>
-          </a:prstGeom>
-          <a:noFill/>
-          <a:ln/>
-        </p:spPr>
-        <p:txBody>
-          <a:bodyPr wrap="square" rtlCol="0" anchor="ctr"/>
-          <a:lstStyle/>
-          <a:p>
-            <a:pPr marL="0" indent="0">
-              <a:buNone/>
-            </a:pPr>
-            <a:r>
-              <a:rPr lang="en-US" sz="850" b="1" dirty="0">
-                <a:solidFill>
-                  <a:srgbClr val="2A9D8F"/>
-                </a:solidFill>
-              </a:rPr>
-              <a:t>✓ 10 risk records loaded, zero impact on existing structures</a:t>
-            </a:r>
-            <a:endParaRPr lang="en-US" sz="850" dirty="0"/>
-          </a:p>
-        </p:txBody>
-      </p:sp>
-      <p:sp>
-        <p:nvSpPr>
-          <p:cNvPr id="12" name="Shape 10"/>
-          <p:cNvSpPr/>
-          <p:nvPr/>
-        </p:nvSpPr>
-        <p:spPr>
-          <a:xfrm>
-            <a:off x="3291840" y="914400"/>
-            <a:ext cx="2834640" cy="3749040"/>
-          </a:xfrm>
-          <a:prstGeom prst="rect">
-            <a:avLst/>
-          </a:prstGeom>
-          <a:solidFill>
-            <a:srgbClr val="FFFFFF"/>
-          </a:solidFill>
-          <a:ln/>
-          <a:effectLst>
-            <a:outerShdw blurRad="50800" dist="25400" dir="8100000" algn="bl" rotWithShape="0">
-              <a:srgbClr val="000000">
-                <a:alpha val="10000"/>
-              </a:srgbClr>
-            </a:outerShdw>
-          </a:effectLst>
-        </p:spPr>
-        <p:txBody>
-          <a:bodyPr/>
-          <a:lstStyle/>
-          <a:p>
-            <a:endParaRPr/>
-          </a:p>
-        </p:txBody>
-      </p:sp>
-      <p:sp>
-        <p:nvSpPr>
-          <p:cNvPr id="13" name="Shape 11"/>
-          <p:cNvSpPr/>
-          <p:nvPr/>
-        </p:nvSpPr>
-        <p:spPr>
-          <a:xfrm>
-            <a:off x="3291840" y="914400"/>
-            <a:ext cx="54864" cy="3749040"/>
-          </a:xfrm>
-          <a:prstGeom prst="rect">
-            <a:avLst/>
-          </a:prstGeom>
-          <a:solidFill>
-            <a:srgbClr val="D4A843"/>
-          </a:solidFill>
-          <a:ln/>
-        </p:spPr>
-        <p:txBody>
-          <a:bodyPr/>
-          <a:lstStyle/>
-          <a:p>
-            <a:endParaRPr/>
-          </a:p>
-        </p:txBody>
-      </p:sp>
-      <p:sp>
-        <p:nvSpPr>
-          <p:cNvPr id="14" name="Text 12"/>
-          <p:cNvSpPr/>
-          <p:nvPr/>
-        </p:nvSpPr>
-        <p:spPr>
-          <a:xfrm>
-            <a:off x="3429000" y="960120"/>
-            <a:ext cx="2560320" cy="228600"/>
-          </a:xfrm>
-          <a:prstGeom prst="rect">
-            <a:avLst/>
-          </a:prstGeom>
-          <a:noFill/>
-          <a:ln/>
-        </p:spPr>
-        <p:txBody>
-          <a:bodyPr wrap="square" rtlCol="0" anchor="ctr"/>
-          <a:lstStyle/>
-          <a:p>
-            <a:pPr marL="0" indent="0">
-              <a:buNone/>
-            </a:pPr>
-            <a:r>
-              <a:rPr lang="en-US" sz="1100" b="1" dirty="0">
-                <a:solidFill>
-                  <a:srgbClr val="1B3A5C"/>
-                </a:solidFill>
-                <a:latin typeface="Georgia" pitchFamily="34" charset="0"/>
-                <a:ea typeface="Georgia" pitchFamily="34" charset="-122"/>
-                <a:cs typeface="Georgia" pitchFamily="34" charset="-120"/>
-              </a:rPr>
-              <a:t>5.2.6 Materialized Views</a:t>
-            </a:r>
-            <a:endParaRPr lang="en-US" sz="1100" dirty="0"/>
-          </a:p>
-        </p:txBody>
-      </p:sp>
-      <p:sp>
-        <p:nvSpPr>
-          <p:cNvPr id="15" name="Text 13"/>
-          <p:cNvSpPr/>
-          <p:nvPr/>
-        </p:nvSpPr>
-        <p:spPr>
-          <a:xfrm>
-            <a:off x="3429000" y="1280160"/>
-            <a:ext cx="2560320" cy="1645920"/>
-          </a:xfrm>
-          <a:prstGeom prst="rect">
-            <a:avLst/>
-          </a:prstGeom>
-          <a:noFill/>
-          <a:ln/>
-        </p:spPr>
-        <p:txBody>
-          <a:bodyPr wrap="square" rtlCol="0" anchor="ctr"/>
-          <a:lstStyle/>
-          <a:p>
-            <a:pPr marL="342900" indent="-342900">
-              <a:spcAft>
-                <a:spcPts val="500"/>
-              </a:spcAft>
-              <a:buSzPct val="100000"/>
-              <a:buChar char="•"/>
-            </a:pPr>
-            <a:r>
-              <a:rPr lang="en-US" sz="900" dirty="0">
-                <a:solidFill>
-                  <a:srgbClr val="1E293B"/>
-                </a:solidFill>
-              </a:rPr>
-              <a:t>vw_GoldMonthlyRevenue implemented:</a:t>
-            </a:r>
-            <a:endParaRPr lang="en-US" sz="900" dirty="0"/>
-          </a:p>
-          <a:p>
-            <a:pPr marL="342900" indent="-342900">
-              <a:spcAft>
-                <a:spcPts val="500"/>
-              </a:spcAft>
-              <a:buSzPct val="100000"/>
-              <a:buChar char="•"/>
-            </a:pPr>
-            <a:r>
-              <a:rPr lang="en-US" sz="900" dirty="0">
-                <a:solidFill>
-                  <a:srgbClr val="1E293B"/>
-                </a:solidFill>
-              </a:rPr>
-              <a:t>• Baseline: 73ms elapsed (62ms CPU)</a:t>
-            </a:r>
-            <a:endParaRPr lang="en-US" sz="900" dirty="0"/>
-          </a:p>
-          <a:p>
-            <a:pPr marL="342900" indent="-342900">
-              <a:spcAft>
-                <a:spcPts val="500"/>
-              </a:spcAft>
-              <a:buSzPct val="100000"/>
-              <a:buChar char="•"/>
-            </a:pPr>
-            <a:r>
-              <a:rPr lang="en-US" sz="900" dirty="0">
-                <a:solidFill>
-                  <a:srgbClr val="1E293B"/>
-                </a:solidFill>
-              </a:rPr>
-              <a:t>• NOEXPAND: 34ms elapsed — 2.1× faster</a:t>
-            </a:r>
-            <a:endParaRPr lang="en-US" sz="900" dirty="0"/>
-          </a:p>
-          <a:p>
-            <a:pPr marL="342900" indent="-342900">
-              <a:spcAft>
-                <a:spcPts val="500"/>
-              </a:spcAft>
-              <a:buSzPct val="100000"/>
-              <a:buChar char="•"/>
-            </a:pPr>
-            <a:r>
-              <a:rPr lang="en-US" sz="900" dirty="0">
-                <a:solidFill>
-                  <a:srgbClr val="1E293B"/>
-                </a:solidFill>
-              </a:rPr>
-              <a:t>• SCHEMABINDING + unique clustered index</a:t>
-            </a:r>
-            <a:endParaRPr lang="en-US" sz="900" dirty="0"/>
-          </a:p>
-          <a:p>
-            <a:pPr marL="342900" indent="-342900">
-              <a:spcAft>
-                <a:spcPts val="500"/>
-              </a:spcAft>
-              <a:buSzPct val="100000"/>
-              <a:buChar char="•"/>
-            </a:pPr>
-            <a:r>
-              <a:rPr lang="en-US" sz="900" b="1" dirty="0">
-                <a:solidFill>
-                  <a:srgbClr val="2A9D8F"/>
-                </a:solidFill>
-              </a:rPr>
-              <a:t>Hybrid: indexed views + SPs for cross-DB</a:t>
-            </a:r>
-            <a:endParaRPr lang="en-US" sz="900" dirty="0"/>
-          </a:p>
-        </p:txBody>
-      </p:sp>
-      <p:sp>
-        <p:nvSpPr>
-          <p:cNvPr id="16" name="Shape 14"/>
-          <p:cNvSpPr/>
-          <p:nvPr/>
-        </p:nvSpPr>
-        <p:spPr>
-          <a:xfrm>
-            <a:off x="3429000" y="3931920"/>
-            <a:ext cx="2560320" cy="548640"/>
-          </a:xfrm>
-          <a:prstGeom prst="rect">
-            <a:avLst/>
-          </a:prstGeom>
-          <a:solidFill>
-            <a:srgbClr val="E8F4F2"/>
-          </a:solidFill>
-          <a:ln/>
-        </p:spPr>
-        <p:txBody>
-          <a:bodyPr/>
-          <a:lstStyle/>
-          <a:p>
-            <a:endParaRPr/>
-          </a:p>
-        </p:txBody>
-      </p:sp>
-      <p:sp>
-        <p:nvSpPr>
-          <p:cNvPr id="17" name="Text 15"/>
-          <p:cNvSpPr/>
-          <p:nvPr/>
-        </p:nvSpPr>
-        <p:spPr>
-          <a:xfrm>
-            <a:off x="3520440" y="3931920"/>
-            <a:ext cx="2377440" cy="548640"/>
-          </a:xfrm>
-          <a:prstGeom prst="rect">
-            <a:avLst/>
-          </a:prstGeom>
-          <a:noFill/>
-          <a:ln/>
-        </p:spPr>
-        <p:txBody>
-          <a:bodyPr wrap="square" rtlCol="0" anchor="ctr"/>
-          <a:lstStyle/>
-          <a:p>
-            <a:pPr marL="0" indent="0">
-              <a:buNone/>
-            </a:pPr>
-            <a:r>
-              <a:rPr lang="en-US" sz="850" b="1" dirty="0">
-                <a:solidFill>
-                  <a:srgbClr val="2A9D8F"/>
-                </a:solidFill>
-              </a:rPr>
-              <a:t>✓ Verified 2.1× speedup (73ms→34ms); production: 4×–6× projected</a:t>
-            </a:r>
-            <a:endParaRPr lang="en-US" sz="850" dirty="0"/>
-          </a:p>
-        </p:txBody>
-      </p:sp>
-      <p:sp>
-        <p:nvSpPr>
-          <p:cNvPr id="18" name="Shape 16"/>
-          <p:cNvSpPr/>
-          <p:nvPr/>
-        </p:nvSpPr>
-        <p:spPr>
-          <a:xfrm>
-            <a:off x="6309360" y="914400"/>
-            <a:ext cx="2834640" cy="3749040"/>
-          </a:xfrm>
-          <a:prstGeom prst="rect">
-            <a:avLst/>
-          </a:prstGeom>
-          <a:solidFill>
-            <a:srgbClr val="FFFFFF"/>
-          </a:solidFill>
-          <a:ln/>
-          <a:effectLst>
-            <a:outerShdw blurRad="50800" dist="25400" dir="8100000" algn="bl" rotWithShape="0">
-              <a:srgbClr val="000000">
-                <a:alpha val="10000"/>
-              </a:srgbClr>
-            </a:outerShdw>
-          </a:effectLst>
-        </p:spPr>
-        <p:txBody>
-          <a:bodyPr/>
-          <a:lstStyle/>
-          <a:p>
-            <a:endParaRPr/>
-          </a:p>
-        </p:txBody>
-      </p:sp>
-      <p:sp>
-        <p:nvSpPr>
-          <p:cNvPr id="19" name="Shape 17"/>
-          <p:cNvSpPr/>
-          <p:nvPr/>
-        </p:nvSpPr>
-        <p:spPr>
-          <a:xfrm>
-            <a:off x="6309360" y="914400"/>
-            <a:ext cx="54864" cy="3749040"/>
-          </a:xfrm>
-          <a:prstGeom prst="rect">
-            <a:avLst/>
-          </a:prstGeom>
-          <a:solidFill>
-            <a:srgbClr val="1B3A5C"/>
-          </a:solidFill>
-          <a:ln/>
-        </p:spPr>
-        <p:txBody>
-          <a:bodyPr/>
-          <a:lstStyle/>
-          <a:p>
-            <a:endParaRPr/>
-          </a:p>
-        </p:txBody>
-      </p:sp>
-      <p:sp>
-        <p:nvSpPr>
-          <p:cNvPr id="20" name="Text 18"/>
-          <p:cNvSpPr/>
-          <p:nvPr/>
-        </p:nvSpPr>
-        <p:spPr>
-          <a:xfrm>
-            <a:off x="6446520" y="960120"/>
-            <a:ext cx="2560320" cy="228600"/>
-          </a:xfrm>
-          <a:prstGeom prst="rect">
-            <a:avLst/>
-          </a:prstGeom>
-          <a:noFill/>
-          <a:ln/>
-        </p:spPr>
-        <p:txBody>
-          <a:bodyPr wrap="square" rtlCol="0" anchor="ctr"/>
-          <a:lstStyle/>
-          <a:p>
-            <a:pPr marL="0" indent="0">
-              <a:buNone/>
-            </a:pPr>
-            <a:r>
-              <a:rPr lang="en-US" sz="1100" b="1" dirty="0">
-                <a:solidFill>
-                  <a:srgbClr val="1B3A5C"/>
-                </a:solidFill>
-                <a:latin typeface="Georgia" pitchFamily="34" charset="0"/>
-                <a:ea typeface="Georgia" pitchFamily="34" charset="-122"/>
-                <a:cs typeface="Georgia" pitchFamily="34" charset="-120"/>
-              </a:rPr>
-              <a:t>5.2.7 Early Arriving Facts</a:t>
-            </a:r>
-            <a:endParaRPr lang="en-US" sz="1100" dirty="0"/>
-          </a:p>
-        </p:txBody>
-      </p:sp>
-      <p:sp>
-        <p:nvSpPr>
-          <p:cNvPr id="21" name="Text 19"/>
-          <p:cNvSpPr/>
-          <p:nvPr/>
-        </p:nvSpPr>
-        <p:spPr>
-          <a:xfrm>
-            <a:off x="6446520" y="1280160"/>
-            <a:ext cx="2560320" cy="1645920"/>
-          </a:xfrm>
-          <a:prstGeom prst="rect">
-            <a:avLst/>
-          </a:prstGeom>
-          <a:noFill/>
-          <a:ln/>
-        </p:spPr>
-        <p:txBody>
-          <a:bodyPr wrap="square" rtlCol="0" anchor="ctr"/>
-          <a:lstStyle/>
-          <a:p>
-            <a:pPr marL="342900" indent="-342900">
-              <a:spcAft>
-                <a:spcPts val="500"/>
-              </a:spcAft>
-              <a:buSzPct val="100000"/>
-              <a:buChar char="•"/>
-            </a:pPr>
-            <a:r>
-              <a:rPr lang="en-US" sz="900" dirty="0">
-                <a:solidFill>
-                  <a:srgbClr val="1E293B"/>
-                </a:solidFill>
-              </a:rPr>
-              <a:t>Verified with TAX-2026-EARLY test case:</a:t>
-            </a:r>
-            <a:endParaRPr lang="en-US" sz="900" dirty="0"/>
-          </a:p>
-          <a:p>
-            <a:pPr marL="342900" indent="-342900">
-              <a:spcAft>
-                <a:spcPts val="500"/>
-              </a:spcAft>
-              <a:buSzPct val="100000"/>
-              <a:buChar char="•"/>
-            </a:pPr>
-            <a:r>
-              <a:rPr lang="en-US" sz="900" dirty="0">
-                <a:solidFill>
-                  <a:srgbClr val="1E293B"/>
-                </a:solidFill>
-              </a:rPr>
-              <a:t>1. Hub created 06:40:14 (business key only)</a:t>
-            </a:r>
-            <a:endParaRPr lang="en-US" sz="900" dirty="0"/>
-          </a:p>
-          <a:p>
-            <a:pPr marL="342900" indent="-342900">
-              <a:spcAft>
-                <a:spcPts val="500"/>
-              </a:spcAft>
-              <a:buSzPct val="100000"/>
-              <a:buChar char="•"/>
-            </a:pPr>
-            <a:r>
-              <a:rPr lang="en-US" sz="900" dirty="0">
-                <a:solidFill>
-                  <a:srgbClr val="1E293B"/>
-                </a:solidFill>
-              </a:rPr>
-              <a:t>2. Link loaded 06:40:15 (no SAT needed)</a:t>
-            </a:r>
-            <a:endParaRPr lang="en-US" sz="900" dirty="0"/>
-          </a:p>
-          <a:p>
-            <a:pPr marL="342900" indent="-342900">
-              <a:spcAft>
-                <a:spcPts val="500"/>
-              </a:spcAft>
-              <a:buSzPct val="100000"/>
-              <a:buChar char="•"/>
-            </a:pPr>
-            <a:r>
-              <a:rPr lang="en-US" sz="900" dirty="0">
-                <a:solidFill>
-                  <a:srgbClr val="1E293B"/>
-                </a:solidFill>
-              </a:rPr>
-              <a:t>3. SAT arrived 06:44:37 (263s later, INSERT only)</a:t>
-            </a:r>
-            <a:endParaRPr lang="en-US" sz="900" dirty="0"/>
-          </a:p>
-          <a:p>
-            <a:pPr marL="342900" indent="-342900">
-              <a:spcAft>
-                <a:spcPts val="500"/>
-              </a:spcAft>
-              <a:buSzPct val="100000"/>
-              <a:buChar char="•"/>
-            </a:pPr>
-            <a:r>
-              <a:rPr lang="en-US" sz="900" b="1" dirty="0">
-                <a:solidFill>
-                  <a:srgbClr val="2A9D8F"/>
-                </a:solidFill>
-              </a:rPr>
-              <a:t>Zero placeholders, zero UPDATEs, zero reconciliation</a:t>
-            </a:r>
-            <a:endParaRPr lang="en-US" sz="900" dirty="0"/>
-          </a:p>
-        </p:txBody>
-      </p:sp>
-      <p:sp>
-        <p:nvSpPr>
-          <p:cNvPr id="22" name="Shape 20"/>
-          <p:cNvSpPr/>
-          <p:nvPr/>
-        </p:nvSpPr>
-        <p:spPr>
-          <a:xfrm>
-            <a:off x="6446520" y="3931920"/>
-            <a:ext cx="2560320" cy="548640"/>
-          </a:xfrm>
-          <a:prstGeom prst="rect">
-            <a:avLst/>
-          </a:prstGeom>
-          <a:solidFill>
-            <a:srgbClr val="E8F4F2"/>
-          </a:solidFill>
-          <a:ln/>
-        </p:spPr>
-        <p:txBody>
-          <a:bodyPr/>
-          <a:lstStyle/>
-          <a:p>
-            <a:endParaRPr/>
-          </a:p>
-        </p:txBody>
-      </p:sp>
-      <p:sp>
-        <p:nvSpPr>
-          <p:cNvPr id="23" name="Text 21"/>
-          <p:cNvSpPr/>
-          <p:nvPr/>
-        </p:nvSpPr>
-        <p:spPr>
-          <a:xfrm>
-            <a:off x="6537960" y="3931920"/>
-            <a:ext cx="2377440" cy="548640"/>
-          </a:xfrm>
-          <a:prstGeom prst="rect">
-            <a:avLst/>
-          </a:prstGeom>
-          <a:noFill/>
-          <a:ln/>
-        </p:spPr>
-        <p:txBody>
-          <a:bodyPr wrap="square" rtlCol="0" anchor="ctr"/>
-          <a:lstStyle/>
-          <a:p>
-            <a:pPr marL="0" indent="0">
-              <a:buNone/>
-            </a:pPr>
-            <a:r>
-              <a:rPr lang="en-US" sz="850" b="1" dirty="0">
-                <a:solidFill>
-                  <a:srgbClr val="2A9D8F"/>
-                </a:solidFill>
-              </a:rPr>
-              <a:t>✓ 4-step timeline proves Hub/SAT separation handles it naturally</a:t>
-            </a:r>
-            <a:endParaRPr lang="en-US" sz="850" dirty="0"/>
-          </a:p>
-        </p:txBody>
-      </p:sp>
-    </p:spTree>
-  </p:cSld>
-  <p:clrMapOvr>
-    <a:masterClrMapping/>
-  </p:clrMapOvr>
-</p:sld>
-</file>
-
-<file path=ppt/slides/slide12.xml><?xml version="1.0" encoding="utf-8"?>
-<p:sld xmlns:a="http://schemas.openxmlformats.org/drawingml/2006/main" xmlns:r="http://schemas.openxmlformats.org/officeDocument/2006/relationships" xmlns:p="http://schemas.openxmlformats.org/presentationml/2006/main">
-  <p:cSld name="Slide 15">
-    <p:bg>
-      <p:bgPr>
-        <a:solidFill>
-          <a:srgbClr val="F7FAFA"/>
-        </a:solidFill>
-        <a:effectLst/>
-      </p:bgPr>
-    </p:bg>
-    <p:spTree>
-      <p:nvGrpSpPr>
-        <p:cNvPr id="1" name=""/>
-        <p:cNvGrpSpPr/>
-        <p:nvPr/>
-      </p:nvGrpSpPr>
-      <p:grpSpPr>
-        <a:xfrm>
-          <a:off x="0" y="0"/>
-          <a:ext cx="0" cy="0"/>
-          <a:chOff x="0" y="0"/>
-          <a:chExt cx="0" cy="0"/>
-        </a:xfrm>
-      </p:grpSpPr>
-      <p:sp>
-        <p:nvSpPr>
-          <p:cNvPr id="2" name="Shape 0"/>
-          <p:cNvSpPr/>
-          <p:nvPr/>
-        </p:nvSpPr>
-        <p:spPr>
-          <a:xfrm>
-            <a:off x="0" y="0"/>
-            <a:ext cx="54864" cy="5143500"/>
-          </a:xfrm>
-          <a:prstGeom prst="rect">
-            <a:avLst/>
-          </a:prstGeom>
-          <a:solidFill>
-            <a:srgbClr val="2A9D8F"/>
-          </a:solidFill>
-          <a:ln/>
-        </p:spPr>
-        <p:txBody>
-          <a:bodyPr/>
-          <a:lstStyle/>
-          <a:p>
-            <a:endParaRPr/>
-          </a:p>
-        </p:txBody>
-      </p:sp>
-      <p:sp>
-        <p:nvSpPr>
-          <p:cNvPr id="3" name="Text 1"/>
-          <p:cNvSpPr/>
-          <p:nvPr/>
-        </p:nvSpPr>
-        <p:spPr>
-          <a:xfrm>
-            <a:off x="8046720" y="4754880"/>
-            <a:ext cx="914400" cy="274320"/>
-          </a:xfrm>
-          <a:prstGeom prst="rect">
-            <a:avLst/>
-          </a:prstGeom>
-          <a:noFill/>
-          <a:ln/>
-        </p:spPr>
-        <p:txBody>
-          <a:bodyPr wrap="square" rtlCol="0" anchor="ctr"/>
-          <a:lstStyle/>
-          <a:p>
-            <a:pPr marL="0" indent="0" algn="r">
-              <a:buNone/>
-            </a:pPr>
-            <a:r>
-              <a:rPr lang="en-US" sz="900" dirty="0">
-                <a:solidFill>
-                  <a:srgbClr val="64748B"/>
-                </a:solidFill>
-              </a:rPr>
-              <a:t>12 / 15</a:t>
-            </a:r>
-            <a:endParaRPr lang="en-US" sz="900" dirty="0"/>
-          </a:p>
-        </p:txBody>
-      </p:sp>
-      <p:sp>
-        <p:nvSpPr>
-          <p:cNvPr id="4" name="Text 2"/>
-          <p:cNvSpPr/>
-          <p:nvPr/>
-        </p:nvSpPr>
-        <p:spPr>
-          <a:xfrm>
-            <a:off x="457200" y="182880"/>
-            <a:ext cx="8229600" cy="502920"/>
-          </a:xfrm>
-          <a:prstGeom prst="rect">
-            <a:avLst/>
-          </a:prstGeom>
-          <a:noFill/>
-          <a:ln/>
-        </p:spPr>
-        <p:txBody>
-          <a:bodyPr wrap="square" rtlCol="0" anchor="ctr"/>
-          <a:lstStyle/>
-          <a:p>
-            <a:pPr marL="0" indent="0">
-              <a:buNone/>
-            </a:pPr>
-            <a:r>
-              <a:rPr lang="en-US" sz="2200" b="1" dirty="0">
-                <a:solidFill>
-                  <a:srgbClr val="1B3A5C"/>
-                </a:solidFill>
-                <a:latin typeface="Georgia" pitchFamily="34" charset="0"/>
-                <a:ea typeface="Georgia" pitchFamily="34" charset="-122"/>
-                <a:cs typeface="Georgia" pitchFamily="34" charset="-120"/>
-              </a:rPr>
-              <a:t>Threats to Validity</a:t>
-            </a:r>
-            <a:endParaRPr lang="en-US" sz="2200" dirty="0"/>
-          </a:p>
-        </p:txBody>
-      </p:sp>
-      <p:sp>
-        <p:nvSpPr>
-          <p:cNvPr id="5" name="Shape 3"/>
-          <p:cNvSpPr/>
-          <p:nvPr/>
-        </p:nvSpPr>
-        <p:spPr>
-          <a:xfrm>
-            <a:off x="457200" y="731520"/>
-            <a:ext cx="1097280" cy="36576"/>
-          </a:xfrm>
-          <a:prstGeom prst="rect">
-            <a:avLst/>
-          </a:prstGeom>
-          <a:solidFill>
-            <a:srgbClr val="2A9D8F"/>
-          </a:solidFill>
-          <a:ln/>
-        </p:spPr>
-        <p:txBody>
-          <a:bodyPr/>
-          <a:lstStyle/>
-          <a:p>
-            <a:endParaRPr/>
-          </a:p>
-        </p:txBody>
-      </p:sp>
-      <p:sp>
-        <p:nvSpPr>
-          <p:cNvPr id="6" name="Shape 4"/>
-          <p:cNvSpPr/>
-          <p:nvPr/>
-        </p:nvSpPr>
-        <p:spPr>
-          <a:xfrm>
-            <a:off x="457200" y="1005840"/>
-            <a:ext cx="8229600" cy="1051560"/>
-          </a:xfrm>
-          <a:prstGeom prst="rect">
-            <a:avLst/>
-          </a:prstGeom>
-          <a:solidFill>
-            <a:srgbClr val="FFFFFF"/>
-          </a:solidFill>
-          <a:ln/>
-          <a:effectLst>
-            <a:outerShdw blurRad="50800" dist="25400" dir="8100000" algn="bl" rotWithShape="0">
-              <a:srgbClr val="000000">
-                <a:alpha val="10000"/>
-              </a:srgbClr>
-            </a:outerShdw>
-          </a:effectLst>
-        </p:spPr>
-        <p:txBody>
-          <a:bodyPr/>
-          <a:lstStyle/>
-          <a:p>
-            <a:endParaRPr/>
-          </a:p>
-        </p:txBody>
-      </p:sp>
-      <p:sp>
-        <p:nvSpPr>
-          <p:cNvPr id="7" name="Shape 5"/>
-          <p:cNvSpPr/>
-          <p:nvPr/>
-        </p:nvSpPr>
-        <p:spPr>
-          <a:xfrm>
-            <a:off x="457200" y="1005840"/>
-            <a:ext cx="54864" cy="1051560"/>
-          </a:xfrm>
-          <a:prstGeom prst="rect">
-            <a:avLst/>
-          </a:prstGeom>
-          <a:solidFill>
-            <a:srgbClr val="2A9D8F"/>
-          </a:solidFill>
-          <a:ln/>
-        </p:spPr>
-        <p:txBody>
-          <a:bodyPr/>
-          <a:lstStyle/>
-          <a:p>
-            <a:endParaRPr/>
-          </a:p>
-        </p:txBody>
-      </p:sp>
-      <p:sp>
-        <p:nvSpPr>
-          <p:cNvPr id="8" name="Text 6"/>
-          <p:cNvSpPr/>
-          <p:nvPr/>
-        </p:nvSpPr>
-        <p:spPr>
-          <a:xfrm>
-            <a:off x="685800" y="1051560"/>
-            <a:ext cx="1828800" cy="274320"/>
-          </a:xfrm>
-          <a:prstGeom prst="rect">
-            <a:avLst/>
-          </a:prstGeom>
-          <a:noFill/>
-          <a:ln/>
-        </p:spPr>
-        <p:txBody>
-          <a:bodyPr wrap="square" rtlCol="0" anchor="ctr"/>
-          <a:lstStyle/>
-          <a:p>
-            <a:pPr marL="0" indent="0">
-              <a:buNone/>
-            </a:pPr>
-            <a:r>
-              <a:rPr lang="en-US" sz="1300" b="1" dirty="0">
-                <a:solidFill>
-                  <a:srgbClr val="1B3A5C"/>
-                </a:solidFill>
-                <a:latin typeface="Georgia" pitchFamily="34" charset="0"/>
-                <a:ea typeface="Georgia" pitchFamily="34" charset="-122"/>
-                <a:cs typeface="Georgia" pitchFamily="34" charset="-120"/>
-              </a:rPr>
-              <a:t>Internal Validity</a:t>
-            </a:r>
-            <a:endParaRPr lang="en-US" sz="1300" dirty="0"/>
-          </a:p>
-        </p:txBody>
-      </p:sp>
-      <p:sp>
-        <p:nvSpPr>
-          <p:cNvPr id="9" name="Text 7"/>
-          <p:cNvSpPr/>
-          <p:nvPr/>
-        </p:nvSpPr>
-        <p:spPr>
-          <a:xfrm>
-            <a:off x="685800" y="1325880"/>
-            <a:ext cx="7772400" cy="640080"/>
-          </a:xfrm>
-          <a:prstGeom prst="rect">
-            <a:avLst/>
-          </a:prstGeom>
-          <a:noFill/>
-          <a:ln/>
-        </p:spPr>
-        <p:txBody>
-          <a:bodyPr wrap="square" rtlCol="0" anchor="t"/>
-          <a:lstStyle/>
-          <a:p>
-            <a:pPr marL="0" indent="0">
-              <a:buNone/>
-            </a:pPr>
-            <a:r>
-              <a:rPr lang="en-US" sz="1050" dirty="0">
-                <a:solidFill>
-                  <a:srgbClr val="1E293B"/>
-                </a:solidFill>
-              </a:rPr>
-              <a:t>Single dev environment (GCP e2-standard-4, 16GB RAM); hardware/config variations could affect observed behavior. Mitigated by running all POC demonstrations under identical conditions.</a:t>
-            </a:r>
-            <a:endParaRPr lang="en-US" sz="1050" dirty="0"/>
-          </a:p>
-        </p:txBody>
-      </p:sp>
-      <p:sp>
-        <p:nvSpPr>
-          <p:cNvPr id="10" name="Shape 8"/>
-          <p:cNvSpPr/>
-          <p:nvPr/>
-        </p:nvSpPr>
-        <p:spPr>
-          <a:xfrm>
-            <a:off x="457200" y="2240280"/>
-            <a:ext cx="8229600" cy="1051560"/>
-          </a:xfrm>
-          <a:prstGeom prst="rect">
-            <a:avLst/>
-          </a:prstGeom>
-          <a:solidFill>
-            <a:srgbClr val="FFFFFF"/>
-          </a:solidFill>
-          <a:ln/>
-          <a:effectLst>
-            <a:outerShdw blurRad="50800" dist="25400" dir="8100000" algn="bl" rotWithShape="0">
-              <a:srgbClr val="000000">
-                <a:alpha val="10000"/>
-              </a:srgbClr>
-            </a:outerShdw>
-          </a:effectLst>
-        </p:spPr>
-        <p:txBody>
-          <a:bodyPr/>
-          <a:lstStyle/>
-          <a:p>
-            <a:endParaRPr/>
-          </a:p>
-        </p:txBody>
-      </p:sp>
-      <p:sp>
-        <p:nvSpPr>
-          <p:cNvPr id="11" name="Shape 9"/>
-          <p:cNvSpPr/>
-          <p:nvPr/>
-        </p:nvSpPr>
-        <p:spPr>
-          <a:xfrm>
-            <a:off x="457200" y="2240280"/>
-            <a:ext cx="54864" cy="1051560"/>
-          </a:xfrm>
-          <a:prstGeom prst="rect">
-            <a:avLst/>
-          </a:prstGeom>
-          <a:solidFill>
-            <a:srgbClr val="1B3A5C"/>
-          </a:solidFill>
-          <a:ln/>
-        </p:spPr>
-        <p:txBody>
-          <a:bodyPr/>
-          <a:lstStyle/>
-          <a:p>
-            <a:endParaRPr/>
-          </a:p>
-        </p:txBody>
-      </p:sp>
-      <p:sp>
-        <p:nvSpPr>
-          <p:cNvPr id="12" name="Text 10"/>
-          <p:cNvSpPr/>
-          <p:nvPr/>
-        </p:nvSpPr>
-        <p:spPr>
-          <a:xfrm>
-            <a:off x="685800" y="2286000"/>
-            <a:ext cx="1828800" cy="274320"/>
-          </a:xfrm>
-          <a:prstGeom prst="rect">
-            <a:avLst/>
-          </a:prstGeom>
-          <a:noFill/>
-          <a:ln/>
-        </p:spPr>
-        <p:txBody>
-          <a:bodyPr wrap="square" rtlCol="0" anchor="ctr"/>
-          <a:lstStyle/>
-          <a:p>
-            <a:pPr marL="0" indent="0">
-              <a:buNone/>
-            </a:pPr>
-            <a:r>
-              <a:rPr lang="en-US" sz="1300" b="1" dirty="0">
-                <a:solidFill>
-                  <a:srgbClr val="1B3A5C"/>
-                </a:solidFill>
-                <a:latin typeface="Georgia" pitchFamily="34" charset="0"/>
-                <a:ea typeface="Georgia" pitchFamily="34" charset="-122"/>
-                <a:cs typeface="Georgia" pitchFamily="34" charset="-120"/>
-              </a:rPr>
-              <a:t>External Validity</a:t>
-            </a:r>
-            <a:endParaRPr lang="en-US" sz="1300" dirty="0"/>
-          </a:p>
-        </p:txBody>
-      </p:sp>
-      <p:sp>
-        <p:nvSpPr>
-          <p:cNvPr id="13" name="Text 11"/>
-          <p:cNvSpPr/>
-          <p:nvPr/>
-        </p:nvSpPr>
-        <p:spPr>
-          <a:xfrm>
-            <a:off x="685800" y="2560320"/>
-            <a:ext cx="7772400" cy="640080"/>
-          </a:xfrm>
-          <a:prstGeom prst="rect">
-            <a:avLst/>
-          </a:prstGeom>
-          <a:noFill/>
-          <a:ln/>
-        </p:spPr>
-        <p:txBody>
-          <a:bodyPr wrap="square" rtlCol="0" anchor="t"/>
-          <a:lstStyle/>
-          <a:p>
-            <a:pPr marL="0" indent="0">
-              <a:buNone/>
-            </a:pPr>
-            <a:r>
-              <a:rPr lang="en-US" sz="1050" dirty="0">
-                <a:solidFill>
-                  <a:srgbClr val="1E293B"/>
-                </a:solidFill>
-              </a:rPr>
-              <a:t>Simulated data verified in companion document (12-point checklist: 9 tables, 58,813 records, 0 orphans, 0 NULLs, realistic distributions). Real-world data introduces missing values and encoding issues not evaluated.</a:t>
-            </a:r>
-            <a:endParaRPr lang="en-US" sz="1050" dirty="0"/>
-          </a:p>
-        </p:txBody>
-      </p:sp>
-      <p:sp>
-        <p:nvSpPr>
-          <p:cNvPr id="14" name="Shape 12"/>
-          <p:cNvSpPr/>
-          <p:nvPr/>
-        </p:nvSpPr>
-        <p:spPr>
-          <a:xfrm>
-            <a:off x="457200" y="3474720"/>
-            <a:ext cx="8229600" cy="1051560"/>
-          </a:xfrm>
-          <a:prstGeom prst="rect">
-            <a:avLst/>
-          </a:prstGeom>
-          <a:solidFill>
-            <a:srgbClr val="FFFFFF"/>
-          </a:solidFill>
-          <a:ln/>
-          <a:effectLst>
-            <a:outerShdw blurRad="50800" dist="25400" dir="8100000" algn="bl" rotWithShape="0">
-              <a:srgbClr val="000000">
-                <a:alpha val="10000"/>
-              </a:srgbClr>
-            </a:outerShdw>
-          </a:effectLst>
-        </p:spPr>
-        <p:txBody>
-          <a:bodyPr/>
-          <a:lstStyle/>
-          <a:p>
-            <a:endParaRPr/>
-          </a:p>
-        </p:txBody>
-      </p:sp>
-      <p:sp>
-        <p:nvSpPr>
-          <p:cNvPr id="15" name="Shape 13"/>
-          <p:cNvSpPr/>
-          <p:nvPr/>
-        </p:nvSpPr>
-        <p:spPr>
-          <a:xfrm>
-            <a:off x="457200" y="3474720"/>
-            <a:ext cx="54864" cy="1051560"/>
-          </a:xfrm>
-          <a:prstGeom prst="rect">
-            <a:avLst/>
-          </a:prstGeom>
-          <a:solidFill>
-            <a:srgbClr val="D4A843"/>
-          </a:solidFill>
-          <a:ln/>
-        </p:spPr>
-        <p:txBody>
-          <a:bodyPr/>
-          <a:lstStyle/>
-          <a:p>
-            <a:endParaRPr/>
-          </a:p>
-        </p:txBody>
-      </p:sp>
-      <p:sp>
-        <p:nvSpPr>
-          <p:cNvPr id="16" name="Text 14"/>
-          <p:cNvSpPr/>
-          <p:nvPr/>
-        </p:nvSpPr>
-        <p:spPr>
-          <a:xfrm>
-            <a:off x="685800" y="3520440"/>
-            <a:ext cx="1828800" cy="274320"/>
-          </a:xfrm>
-          <a:prstGeom prst="rect">
-            <a:avLst/>
-          </a:prstGeom>
-          <a:noFill/>
-          <a:ln/>
-        </p:spPr>
-        <p:txBody>
-          <a:bodyPr wrap="square" rtlCol="0" anchor="ctr"/>
-          <a:lstStyle/>
-          <a:p>
-            <a:pPr marL="0" indent="0">
-              <a:buNone/>
-            </a:pPr>
-            <a:r>
-              <a:rPr lang="en-US" sz="1300" b="1" dirty="0">
-                <a:solidFill>
-                  <a:srgbClr val="1B3A5C"/>
-                </a:solidFill>
-                <a:latin typeface="Georgia" pitchFamily="34" charset="0"/>
-                <a:ea typeface="Georgia" pitchFamily="34" charset="-122"/>
-                <a:cs typeface="Georgia" pitchFamily="34" charset="-120"/>
-              </a:rPr>
-              <a:t>Construct Validity</a:t>
-            </a:r>
-            <a:endParaRPr lang="en-US" sz="1300" dirty="0"/>
-          </a:p>
-        </p:txBody>
-      </p:sp>
-      <p:sp>
-        <p:nvSpPr>
-          <p:cNvPr id="17" name="Text 15"/>
-          <p:cNvSpPr/>
-          <p:nvPr/>
-        </p:nvSpPr>
-        <p:spPr>
-          <a:xfrm>
-            <a:off x="685800" y="3794760"/>
-            <a:ext cx="7772400" cy="640080"/>
-          </a:xfrm>
-          <a:prstGeom prst="rect">
-            <a:avLst/>
-          </a:prstGeom>
-          <a:noFill/>
-          <a:ln/>
-        </p:spPr>
-        <p:txBody>
-          <a:bodyPr wrap="square" rtlCol="0" anchor="t"/>
-          <a:lstStyle/>
-          <a:p>
-            <a:pPr marL="0" indent="0">
-              <a:buNone/>
-            </a:pPr>
-            <a:r>
-              <a:rPr lang="en-US" sz="1050" dirty="0">
-                <a:solidFill>
-                  <a:srgbClr val="1E293B"/>
-                </a:solidFill>
-              </a:rPr>
-              <a:t>Evaluation criteria selected from problem statement and prior studies [9][10][11]. Additional criteria such as data governance, real-time processing, and team skill requirements may also be relevant. Quantitative performance benchmarking (ETL load times, query performance, scalability) identified as future work to strengthen conclusions.</a:t>
-            </a:r>
-            <a:endParaRPr lang="en-US" sz="1050" dirty="0"/>
-          </a:p>
-        </p:txBody>
-      </p:sp>
-    </p:spTree>
-  </p:cSld>
-  <p:clrMapOvr>
-    <a:masterClrMapping/>
-  </p:clrMapOvr>
-</p:sld>
-</file>
-
-<file path=ppt/slides/slide13.xml><?xml version="1.0" encoding="utf-8"?>
 <p:sld xmlns:a="http://schemas.openxmlformats.org/drawingml/2006/main" xmlns:r="http://schemas.openxmlformats.org/officeDocument/2006/relationships" xmlns:p="http://schemas.openxmlformats.org/presentationml/2006/main">
   <p:cSld name="Slide 16">
     <p:bg>
@@ -5133,7 +3411,7 @@
                   <a:srgbClr val="64748B"/>
                 </a:solidFill>
               </a:rPr>
-              <a:t>13 / 15</a:t>
+              <a:t>11 / 13</a:t>
             </a:r>
             <a:endParaRPr lang="en-US" sz="900" dirty="0"/>
           </a:p>
@@ -5609,7 +3887,7 @@
 </p:sld>
 </file>
 
-<file path=ppt/slides/slide14.xml><?xml version="1.0" encoding="utf-8"?>
+<file path=ppt/slides/slide12.xml><?xml version="1.0" encoding="utf-8"?>
 <p:sld xmlns:a="http://schemas.openxmlformats.org/drawingml/2006/main" xmlns:r="http://schemas.openxmlformats.org/officeDocument/2006/relationships" xmlns:p="http://schemas.openxmlformats.org/presentationml/2006/main">
   <p:cSld name="Slide 17">
     <p:bg>
@@ -5691,7 +3969,7 @@
                   <a:srgbClr val="64748B"/>
                 </a:solidFill>
               </a:rPr>
-              <a:t>14 / 15</a:t>
+              <a:t>12 / 13</a:t>
             </a:r>
             <a:endParaRPr lang="en-US" sz="900" dirty="0"/>
           </a:p>
@@ -6250,7 +4528,7 @@
       </p:sp>
       <p:sp>
         <p:nvSpPr>
-          <p:cNvPr id="21" name="Shape 19"/>
+          <p:cNvPr id="24" name="Shape 22"/>
           <p:cNvSpPr/>
           <p:nvPr/>
         </p:nvSpPr>
@@ -6284,7 +4562,7 @@
       </p:sp>
       <p:sp>
         <p:nvSpPr>
-          <p:cNvPr id="22" name="Shape 20"/>
+          <p:cNvPr id="25" name="Shape 23"/>
           <p:cNvSpPr/>
           <p:nvPr/>
         </p:nvSpPr>
@@ -6311,7 +4589,7 @@
       </p:sp>
       <p:sp>
         <p:nvSpPr>
-          <p:cNvPr id="23" name="Text 21"/>
+          <p:cNvPr id="26" name="Text 24"/>
           <p:cNvSpPr/>
           <p:nvPr/>
         </p:nvSpPr>
@@ -6339,7 +4617,7 @@
                   <a:srgbClr val="1E293B"/>
                 </a:solidFill>
               </a:rPr>
-              <a:t>6. Cloud migration path: Azure Synapse / SQL Managed Instance for elastic scaling and managed infrastructure</a:t>
+              <a:t>6. Advanced analytics: ML models on Gold layer for compliance risk scoring, revenue forecasting, fraud detection, and anomaly detection</a:t>
             </a:r>
             <a:endParaRPr lang="en-US" sz="1050" dirty="0"/>
           </a:p>
@@ -6353,7 +4631,7 @@
 </p:sld>
 </file>
 
-<file path=ppt/slides/slide15.xml><?xml version="1.0" encoding="utf-8"?>
+<file path=ppt/slides/slide13.xml><?xml version="1.0" encoding="utf-8"?>
 <p:sld xmlns:a="http://schemas.openxmlformats.org/drawingml/2006/main" xmlns:r="http://schemas.openxmlformats.org/officeDocument/2006/relationships" xmlns:p="http://schemas.openxmlformats.org/presentationml/2006/main">
   <p:cSld name="Slide 18">
     <p:bg>
@@ -6688,7 +4966,7 @@
                   <a:srgbClr val="64748B"/>
                 </a:solidFill>
               </a:rPr>
-              <a:t>15 / 15</a:t>
+              <a:t>13 / 13</a:t>
             </a:r>
             <a:endParaRPr lang="en-US" sz="900" dirty="0"/>
           </a:p>
@@ -6797,7 +5075,7 @@
                     <a:srgbClr val="64748B"/>
                   </a:solidFill>
                 </a:rPr>
-                <a:t>2 / 18</a:t>
+                <a:t>2 / 13</a:t>
               </a:r>
               <a:endParaRPr lang="en-US" sz="900" dirty="0"/>
             </a:p>
@@ -7781,7 +6059,7 @@
                   <a:srgbClr val="64748B"/>
                 </a:solidFill>
               </a:rPr>
-              <a:t>3 / 15</a:t>
+              <a:t>3 / 13</a:t>
             </a:r>
             <a:endParaRPr lang="en-US" sz="900" dirty="0"/>
           </a:p>
@@ -8578,7 +6856,7 @@
                   <a:srgbClr val="64748B"/>
                 </a:solidFill>
               </a:rPr>
-              <a:t>4 / 15</a:t>
+              <a:t>4 / 13</a:t>
             </a:r>
             <a:endParaRPr lang="en-US" sz="900" dirty="0"/>
           </a:p>
@@ -9137,7 +7415,7 @@
                   <a:srgbClr val="64748B"/>
                 </a:solidFill>
               </a:rPr>
-              <a:t>5 / 15</a:t>
+              <a:t>5 / 13</a:t>
             </a:r>
             <a:endParaRPr lang="en-US" sz="900" dirty="0"/>
           </a:p>
@@ -9878,7 +8156,7 @@
                   <a:srgbClr val="64748B"/>
                 </a:solidFill>
               </a:rPr>
-              <a:t>6 / 15</a:t>
+              <a:t>6 / 13</a:t>
             </a:r>
             <a:endParaRPr lang="en-US" sz="900" dirty="0"/>
           </a:p>
@@ -9959,14 +8237,14 @@
           <p:nvPr>
             <p:extLst>
               <p:ext uri="{D42A27DB-BD31-4B8C-83A1-F6EECF244321}">
-                <p14:modId xmlns:p14="http://schemas.microsoft.com/office/powerpoint/2010/main" val="1579011935"/>
+                <p14:modId xmlns:p14="http://schemas.microsoft.com/office/powerpoint/2010/main" val="2555424238"/>
               </p:ext>
             </p:extLst>
           </p:nvPr>
         </p:nvGraphicFramePr>
         <p:xfrm>
           <a:off x="274320" y="1005840"/>
-          <a:ext cx="8595360" cy="1897380"/>
+          <a:ext cx="8595360" cy="3406139"/>
         </p:xfrm>
         <a:graphic>
           <a:graphicData uri="http://schemas.openxmlformats.org/drawingml/2006/table">
@@ -10009,13 +8287,13 @@
                   </a:extLst>
                 </a:gridCol>
               </a:tblGrid>
-              <a:tr h="0">
+              <a:tr h="396699">
                 <a:tc>
                   <a:txBody>
                     <a:bodyPr/>
                     <a:lstStyle/>
                     <a:p>
-                      <a:pPr marL="0" indent="0">
+                      <a:pPr marL="0" indent="0" algn="ctr">
                         <a:buNone/>
                       </a:pPr>
                       <a:r>
@@ -10076,7 +8354,7 @@
                     <a:bodyPr/>
                     <a:lstStyle/>
                     <a:p>
-                      <a:pPr marL="0" indent="0">
+                      <a:pPr marL="0" indent="0" algn="ctr">
                         <a:buNone/>
                       </a:pPr>
                       <a:r>
@@ -10137,7 +8415,7 @@
                     <a:bodyPr/>
                     <a:lstStyle/>
                     <a:p>
-                      <a:pPr marL="0" indent="0">
+                      <a:pPr marL="0" indent="0" algn="ctr">
                         <a:buNone/>
                       </a:pPr>
                       <a:r>
@@ -10198,7 +8476,7 @@
                     <a:bodyPr/>
                     <a:lstStyle/>
                     <a:p>
-                      <a:pPr marL="0" indent="0">
+                      <a:pPr marL="0" indent="0" algn="ctr">
                         <a:buNone/>
                       </a:pPr>
                       <a:r>
@@ -10259,7 +8537,7 @@
                     <a:bodyPr/>
                     <a:lstStyle/>
                     <a:p>
-                      <a:pPr marL="0" indent="0">
+                      <a:pPr marL="0" indent="0" algn="ctr">
                         <a:buNone/>
                       </a:pPr>
                       <a:r>
@@ -10321,7 +8599,7 @@
                   </a:ext>
                 </a:extLst>
               </a:tr>
-              <a:tr h="0">
+              <a:tr h="601888">
                 <a:tc>
                   <a:txBody>
                     <a:bodyPr/>
@@ -10675,7 +8953,7 @@
                   </a:ext>
                 </a:extLst>
               </a:tr>
-              <a:tr h="0">
+              <a:tr h="601888">
                 <a:tc>
                   <a:txBody>
                     <a:bodyPr/>
@@ -11043,7 +9321,7 @@
                   </a:ext>
                 </a:extLst>
               </a:tr>
-              <a:tr h="0">
+              <a:tr h="601888">
                 <a:tc>
                   <a:txBody>
                     <a:bodyPr/>
@@ -11397,7 +9675,7 @@
                   </a:ext>
                 </a:extLst>
               </a:tr>
-              <a:tr h="0">
+              <a:tr h="601888">
                 <a:tc>
                   <a:txBody>
                     <a:bodyPr/>
@@ -11751,7 +10029,7 @@
                   </a:ext>
                 </a:extLst>
               </a:tr>
-              <a:tr h="0">
+              <a:tr h="601888">
                 <a:tc>
                   <a:txBody>
                     <a:bodyPr/>
@@ -12199,7 +10477,7 @@
                   <a:srgbClr val="64748B"/>
                 </a:solidFill>
               </a:rPr>
-              <a:t>7 / 15</a:t>
+              <a:t>7 / 13</a:t>
             </a:r>
             <a:endParaRPr lang="en-US" sz="900" dirty="0"/>
           </a:p>
@@ -13489,7 +11767,7 @@
                   <a:srgbClr val="1E293B"/>
                 </a:solidFill>
               </a:rPr>
-              <a:t>ETL_Configuration — Entity registry &amp; load order</a:t>
+              <a:t>ETL_Process — Entity registry &amp; load order</a:t>
             </a:r>
             <a:endParaRPr lang="en-US" sz="900" dirty="0"/>
           </a:p>
@@ -13543,7 +11821,7 @@
                   <a:srgbClr val="1E293B"/>
                 </a:solidFill>
               </a:rPr>
-              <a:t>ETL_ErrorLog / DataQualityLog — Error &amp; DQ</a:t>
+              <a:t>ETL_ErrorLog — Error capture &amp; diagnostics</a:t>
             </a:r>
             <a:endParaRPr lang="en-US" sz="900" dirty="0"/>
           </a:p>
@@ -13866,7 +12144,7 @@
                   <a:srgbClr val="64748B"/>
                 </a:solidFill>
               </a:rPr>
-              <a:t>8 / 15</a:t>
+              <a:t>8 / 13</a:t>
             </a:r>
             <a:endParaRPr lang="en-US" sz="900" dirty="0"/>
           </a:p>
@@ -15777,7 +14055,7 @@
                   <a:srgbClr val="64748B"/>
                 </a:solidFill>
               </a:rPr>
-              <a:t>9 / 15</a:t>
+              <a:t>9 / 13</a:t>
             </a:r>
             <a:endParaRPr lang="en-US" sz="900" dirty="0"/>
           </a:p>
@@ -15894,14 +14172,14 @@
           <p:nvPr>
             <p:extLst>
               <p:ext uri="{D42A27DB-BD31-4B8C-83A1-F6EECF244321}">
-                <p14:modId xmlns:p14="http://schemas.microsoft.com/office/powerpoint/2010/main" val="1579011935"/>
+                <p14:modId xmlns:p14="http://schemas.microsoft.com/office/powerpoint/2010/main" val="1143012250"/>
               </p:ext>
             </p:extLst>
           </p:nvPr>
         </p:nvGraphicFramePr>
         <p:xfrm>
           <a:off x="274320" y="1280160"/>
-          <a:ext cx="8595360" cy="1714500"/>
+          <a:ext cx="8595360" cy="2748744"/>
         </p:xfrm>
         <a:graphic>
           <a:graphicData uri="http://schemas.openxmlformats.org/drawingml/2006/table">
@@ -15937,13 +14215,13 @@
                   </a:extLst>
                 </a:gridCol>
               </a:tblGrid>
-              <a:tr h="0">
+              <a:tr h="299283">
                 <a:tc>
                   <a:txBody>
                     <a:bodyPr/>
                     <a:lstStyle/>
                     <a:p>
-                      <a:pPr marL="0" indent="0">
+                      <a:pPr marL="0" indent="0" algn="ctr">
                         <a:buNone/>
                       </a:pPr>
                       <a:r>
@@ -16004,7 +14282,7 @@
                     <a:bodyPr/>
                     <a:lstStyle/>
                     <a:p>
-                      <a:pPr marL="0" indent="0">
+                      <a:pPr marL="0" indent="0" algn="ctr">
                         <a:buNone/>
                       </a:pPr>
                       <a:r>
@@ -16065,7 +14343,7 @@
                     <a:bodyPr/>
                     <a:lstStyle/>
                     <a:p>
-                      <a:pPr marL="0" indent="0">
+                      <a:pPr marL="0" indent="0" algn="ctr">
                         <a:buNone/>
                       </a:pPr>
                       <a:r>
@@ -16126,7 +14404,7 @@
                     <a:bodyPr/>
                     <a:lstStyle/>
                     <a:p>
-                      <a:pPr marL="0" indent="0">
+                      <a:pPr marL="0" indent="0" algn="ctr">
                         <a:buNone/>
                       </a:pPr>
                       <a:r>
@@ -16188,7 +14466,760 @@
                   </a:ext>
                 </a:extLst>
               </a:tr>
+              <a:tr h="288963">
+                <a:tc>
+                  <a:txBody>
+                    <a:bodyPr/>
+                    <a:lstStyle/>
+                    <a:p>
+                      <a:pPr marL="0" indent="0">
+                        <a:buNone/>
+                      </a:pPr>
+                      <a:r>
+                        <a:rPr lang="en-US" sz="800" b="1" dirty="0">
+                          <a:solidFill>
+                            <a:srgbClr val="1B3A5C"/>
+                          </a:solidFill>
+                        </a:rPr>
+                        <a:t>Category</a:t>
+                      </a:r>
+                      <a:endParaRPr lang="en-US" sz="800" dirty="0"/>
+                    </a:p>
+                  </a:txBody>
+                  <a:tcPr>
+                    <a:lnL w="6350" cap="flat" cmpd="sng" algn="ctr">
+                      <a:solidFill>
+                        <a:srgbClr val="E2E8F0"/>
+                      </a:solidFill>
+                      <a:prstDash val="solid"/>
+                      <a:round/>
+                      <a:headEnd type="none" w="med" len="med"/>
+                      <a:tailEnd type="none" w="med" len="med"/>
+                    </a:lnL>
+                    <a:lnR w="6350" cap="flat" cmpd="sng" algn="ctr">
+                      <a:solidFill>
+                        <a:srgbClr val="E2E8F0"/>
+                      </a:solidFill>
+                      <a:prstDash val="solid"/>
+                      <a:round/>
+                      <a:headEnd type="none" w="med" len="med"/>
+                      <a:tailEnd type="none" w="med" len="med"/>
+                    </a:lnR>
+                    <a:lnT w="6350" cap="flat" cmpd="sng" algn="ctr">
+                      <a:solidFill>
+                        <a:srgbClr val="E2E8F0"/>
+                      </a:solidFill>
+                      <a:prstDash val="solid"/>
+                      <a:round/>
+                      <a:headEnd type="none" w="med" len="med"/>
+                      <a:tailEnd type="none" w="med" len="med"/>
+                    </a:lnT>
+                    <a:lnB w="6350" cap="flat" cmpd="sng" algn="ctr">
+                      <a:solidFill>
+                        <a:srgbClr val="E2E8F0"/>
+                      </a:solidFill>
+                      <a:prstDash val="solid"/>
+                      <a:round/>
+                      <a:headEnd type="none" w="med" len="med"/>
+                      <a:tailEnd type="none" w="med" len="med"/>
+                    </a:lnB>
+                    <a:solidFill>
+                      <a:srgbClr val="FFFFFF"/>
+                    </a:solidFill>
+                  </a:tcPr>
+                </a:tc>
+                <a:tc>
+                  <a:txBody>
+                    <a:bodyPr/>
+                    <a:lstStyle/>
+                    <a:p>
+                      <a:pPr marL="0" indent="0">
+                        <a:buNone/>
+                      </a:pPr>
+                      <a:r>
+                        <a:rPr lang="en-US" sz="800" dirty="0">
+                          <a:solidFill>
+                            <a:srgbClr val="1E293B"/>
+                          </a:solidFill>
+                        </a:rPr>
+                        <a:t>Lookup</a:t>
+                      </a:r>
+                      <a:endParaRPr lang="en-US" sz="800" dirty="0"/>
+                    </a:p>
+                  </a:txBody>
+                  <a:tcPr>
+                    <a:lnL w="6350" cap="flat" cmpd="sng" algn="ctr">
+                      <a:solidFill>
+                        <a:srgbClr val="E2E8F0"/>
+                      </a:solidFill>
+                      <a:prstDash val="solid"/>
+                      <a:round/>
+                      <a:headEnd type="none" w="med" len="med"/>
+                      <a:tailEnd type="none" w="med" len="med"/>
+                    </a:lnL>
+                    <a:lnR w="6350" cap="flat" cmpd="sng" algn="ctr">
+                      <a:solidFill>
+                        <a:srgbClr val="E2E8F0"/>
+                      </a:solidFill>
+                      <a:prstDash val="solid"/>
+                      <a:round/>
+                      <a:headEnd type="none" w="med" len="med"/>
+                      <a:tailEnd type="none" w="med" len="med"/>
+                    </a:lnR>
+                    <a:lnT w="6350" cap="flat" cmpd="sng" algn="ctr">
+                      <a:solidFill>
+                        <a:srgbClr val="E2E8F0"/>
+                      </a:solidFill>
+                      <a:prstDash val="solid"/>
+                      <a:round/>
+                      <a:headEnd type="none" w="med" len="med"/>
+                      <a:tailEnd type="none" w="med" len="med"/>
+                    </a:lnT>
+                    <a:lnB w="6350" cap="flat" cmpd="sng" algn="ctr">
+                      <a:solidFill>
+                        <a:srgbClr val="E2E8F0"/>
+                      </a:solidFill>
+                      <a:prstDash val="solid"/>
+                      <a:round/>
+                      <a:headEnd type="none" w="med" len="med"/>
+                      <a:tailEnd type="none" w="med" len="med"/>
+                    </a:lnB>
+                    <a:solidFill>
+                      <a:srgbClr val="FFFFFF"/>
+                    </a:solidFill>
+                  </a:tcPr>
+                </a:tc>
+                <a:tc>
+                  <a:txBody>
+                    <a:bodyPr/>
+                    <a:lstStyle/>
+                    <a:p>
+                      <a:pPr marL="0" indent="0">
+                        <a:buNone/>
+                      </a:pPr>
+                      <a:r>
+                        <a:rPr lang="en-US" sz="800" dirty="0">
+                          <a:solidFill>
+                            <a:srgbClr val="1E293B"/>
+                          </a:solidFill>
+                        </a:rPr>
+                        <a:t>Taxpayer categories (Individual, SME, Corp)</a:t>
+                      </a:r>
+                      <a:endParaRPr lang="en-US" sz="800" dirty="0"/>
+                    </a:p>
+                  </a:txBody>
+                  <a:tcPr>
+                    <a:lnL w="6350" cap="flat" cmpd="sng" algn="ctr">
+                      <a:solidFill>
+                        <a:srgbClr val="E2E8F0"/>
+                      </a:solidFill>
+                      <a:prstDash val="solid"/>
+                      <a:round/>
+                      <a:headEnd type="none" w="med" len="med"/>
+                      <a:tailEnd type="none" w="med" len="med"/>
+                    </a:lnL>
+                    <a:lnR w="6350" cap="flat" cmpd="sng" algn="ctr">
+                      <a:solidFill>
+                        <a:srgbClr val="E2E8F0"/>
+                      </a:solidFill>
+                      <a:prstDash val="solid"/>
+                      <a:round/>
+                      <a:headEnd type="none" w="med" len="med"/>
+                      <a:tailEnd type="none" w="med" len="med"/>
+                    </a:lnR>
+                    <a:lnT w="6350" cap="flat" cmpd="sng" algn="ctr">
+                      <a:solidFill>
+                        <a:srgbClr val="E2E8F0"/>
+                      </a:solidFill>
+                      <a:prstDash val="solid"/>
+                      <a:round/>
+                      <a:headEnd type="none" w="med" len="med"/>
+                      <a:tailEnd type="none" w="med" len="med"/>
+                    </a:lnT>
+                    <a:lnB w="6350" cap="flat" cmpd="sng" algn="ctr">
+                      <a:solidFill>
+                        <a:srgbClr val="E2E8F0"/>
+                      </a:solidFill>
+                      <a:prstDash val="solid"/>
+                      <a:round/>
+                      <a:headEnd type="none" w="med" len="med"/>
+                      <a:tailEnd type="none" w="med" len="med"/>
+                    </a:lnB>
+                    <a:solidFill>
+                      <a:srgbClr val="FFFFFF"/>
+                    </a:solidFill>
+                  </a:tcPr>
+                </a:tc>
+                <a:tc>
+                  <a:txBody>
+                    <a:bodyPr/>
+                    <a:lstStyle/>
+                    <a:p>
+                      <a:pPr marL="0" indent="0">
+                        <a:buNone/>
+                      </a:pPr>
+                      <a:r>
+                        <a:rPr lang="en-US" sz="800" b="1" dirty="0">
+                          <a:solidFill>
+                            <a:srgbClr val="2A9D8F"/>
+                          </a:solidFill>
+                        </a:rPr>
+                        <a:t>5</a:t>
+                      </a:r>
+                      <a:endParaRPr lang="en-US" sz="800" dirty="0"/>
+                    </a:p>
+                  </a:txBody>
+                  <a:tcPr>
+                    <a:lnL w="6350" cap="flat" cmpd="sng" algn="ctr">
+                      <a:solidFill>
+                        <a:srgbClr val="E2E8F0"/>
+                      </a:solidFill>
+                      <a:prstDash val="solid"/>
+                      <a:round/>
+                      <a:headEnd type="none" w="med" len="med"/>
+                      <a:tailEnd type="none" w="med" len="med"/>
+                    </a:lnL>
+                    <a:lnR w="6350" cap="flat" cmpd="sng" algn="ctr">
+                      <a:solidFill>
+                        <a:srgbClr val="E2E8F0"/>
+                      </a:solidFill>
+                      <a:prstDash val="solid"/>
+                      <a:round/>
+                      <a:headEnd type="none" w="med" len="med"/>
+                      <a:tailEnd type="none" w="med" len="med"/>
+                    </a:lnR>
+                    <a:lnT w="6350" cap="flat" cmpd="sng" algn="ctr">
+                      <a:solidFill>
+                        <a:srgbClr val="E2E8F0"/>
+                      </a:solidFill>
+                      <a:prstDash val="solid"/>
+                      <a:round/>
+                      <a:headEnd type="none" w="med" len="med"/>
+                      <a:tailEnd type="none" w="med" len="med"/>
+                    </a:lnT>
+                    <a:lnB w="6350" cap="flat" cmpd="sng" algn="ctr">
+                      <a:solidFill>
+                        <a:srgbClr val="E2E8F0"/>
+                      </a:solidFill>
+                      <a:prstDash val="solid"/>
+                      <a:round/>
+                      <a:headEnd type="none" w="med" len="med"/>
+                      <a:tailEnd type="none" w="med" len="med"/>
+                    </a:lnB>
+                    <a:solidFill>
+                      <a:srgbClr val="FFFFFF"/>
+                    </a:solidFill>
+                  </a:tcPr>
+                </a:tc>
+                <a:extLst>
+                  <a:ext uri="{0D108BD9-81ED-4DB2-BD59-A6C34878D82A}">
+                    <a16:rowId xmlns:a16="http://schemas.microsoft.com/office/drawing/2014/main" val="10003"/>
+                  </a:ext>
+                </a:extLst>
+              </a:tr>
               <a:tr h="0">
+                <a:tc>
+                  <a:txBody>
+                    <a:bodyPr/>
+                    <a:lstStyle/>
+                    <a:p>
+                      <a:pPr marL="0" indent="0">
+                        <a:buNone/>
+                      </a:pPr>
+                      <a:r>
+                        <a:rPr lang="en-US" sz="800" b="1" dirty="0">
+                          <a:solidFill>
+                            <a:srgbClr val="1B3A5C"/>
+                          </a:solidFill>
+                        </a:rPr>
+                        <a:t>Structure</a:t>
+                      </a:r>
+                      <a:endParaRPr lang="en-US" sz="800" dirty="0"/>
+                    </a:p>
+                  </a:txBody>
+                  <a:tcPr>
+                    <a:lnL w="6350" cap="flat" cmpd="sng" algn="ctr">
+                      <a:solidFill>
+                        <a:srgbClr val="E2E8F0"/>
+                      </a:solidFill>
+                      <a:prstDash val="solid"/>
+                      <a:round/>
+                      <a:headEnd type="none" w="med" len="med"/>
+                      <a:tailEnd type="none" w="med" len="med"/>
+                    </a:lnL>
+                    <a:lnR w="6350" cap="flat" cmpd="sng" algn="ctr">
+                      <a:solidFill>
+                        <a:srgbClr val="E2E8F0"/>
+                      </a:solidFill>
+                      <a:prstDash val="solid"/>
+                      <a:round/>
+                      <a:headEnd type="none" w="med" len="med"/>
+                      <a:tailEnd type="none" w="med" len="med"/>
+                    </a:lnR>
+                    <a:lnT w="6350" cap="flat" cmpd="sng" algn="ctr">
+                      <a:solidFill>
+                        <a:srgbClr val="E2E8F0"/>
+                      </a:solidFill>
+                      <a:prstDash val="solid"/>
+                      <a:round/>
+                      <a:headEnd type="none" w="med" len="med"/>
+                      <a:tailEnd type="none" w="med" len="med"/>
+                    </a:lnT>
+                    <a:lnB w="6350" cap="flat" cmpd="sng" algn="ctr">
+                      <a:solidFill>
+                        <a:srgbClr val="E2E8F0"/>
+                      </a:solidFill>
+                      <a:prstDash val="solid"/>
+                      <a:round/>
+                      <a:headEnd type="none" w="med" len="med"/>
+                      <a:tailEnd type="none" w="med" len="med"/>
+                    </a:lnB>
+                    <a:solidFill>
+                      <a:srgbClr val="FFFFFF"/>
+                    </a:solidFill>
+                  </a:tcPr>
+                </a:tc>
+                <a:tc>
+                  <a:txBody>
+                    <a:bodyPr/>
+                    <a:lstStyle/>
+                    <a:p>
+                      <a:pPr marL="0" indent="0">
+                        <a:buNone/>
+                      </a:pPr>
+                      <a:r>
+                        <a:rPr lang="en-US" sz="800" dirty="0">
+                          <a:solidFill>
+                            <a:srgbClr val="1E293B"/>
+                          </a:solidFill>
+                        </a:rPr>
+                        <a:t>Lookup</a:t>
+                      </a:r>
+                      <a:endParaRPr lang="en-US" sz="800" dirty="0"/>
+                    </a:p>
+                  </a:txBody>
+                  <a:tcPr>
+                    <a:lnL w="6350" cap="flat" cmpd="sng" algn="ctr">
+                      <a:solidFill>
+                        <a:srgbClr val="E2E8F0"/>
+                      </a:solidFill>
+                      <a:prstDash val="solid"/>
+                      <a:round/>
+                      <a:headEnd type="none" w="med" len="med"/>
+                      <a:tailEnd type="none" w="med" len="med"/>
+                    </a:lnL>
+                    <a:lnR w="6350" cap="flat" cmpd="sng" algn="ctr">
+                      <a:solidFill>
+                        <a:srgbClr val="E2E8F0"/>
+                      </a:solidFill>
+                      <a:prstDash val="solid"/>
+                      <a:round/>
+                      <a:headEnd type="none" w="med" len="med"/>
+                      <a:tailEnd type="none" w="med" len="med"/>
+                    </a:lnR>
+                    <a:lnT w="6350" cap="flat" cmpd="sng" algn="ctr">
+                      <a:solidFill>
+                        <a:srgbClr val="E2E8F0"/>
+                      </a:solidFill>
+                      <a:prstDash val="solid"/>
+                      <a:round/>
+                      <a:headEnd type="none" w="med" len="med"/>
+                      <a:tailEnd type="none" w="med" len="med"/>
+                    </a:lnT>
+                    <a:lnB w="6350" cap="flat" cmpd="sng" algn="ctr">
+                      <a:solidFill>
+                        <a:srgbClr val="E2E8F0"/>
+                      </a:solidFill>
+                      <a:prstDash val="solid"/>
+                      <a:round/>
+                      <a:headEnd type="none" w="med" len="med"/>
+                      <a:tailEnd type="none" w="med" len="med"/>
+                    </a:lnB>
+                    <a:solidFill>
+                      <a:srgbClr val="FFFFFF"/>
+                    </a:solidFill>
+                  </a:tcPr>
+                </a:tc>
+                <a:tc>
+                  <a:txBody>
+                    <a:bodyPr/>
+                    <a:lstStyle/>
+                    <a:p>
+                      <a:pPr marL="0" indent="0">
+                        <a:buNone/>
+                      </a:pPr>
+                      <a:r>
+                        <a:rPr lang="en-US" sz="800" dirty="0">
+                          <a:solidFill>
+                            <a:srgbClr val="1E293B"/>
+                          </a:solidFill>
+                        </a:rPr>
+                        <a:t>Business structure types (Individual, Partnership, Corp)</a:t>
+                      </a:r>
+                      <a:endParaRPr lang="en-US" sz="800" dirty="0"/>
+                    </a:p>
+                  </a:txBody>
+                  <a:tcPr>
+                    <a:lnL w="6350" cap="flat" cmpd="sng" algn="ctr">
+                      <a:solidFill>
+                        <a:srgbClr val="E2E8F0"/>
+                      </a:solidFill>
+                      <a:prstDash val="solid"/>
+                      <a:round/>
+                      <a:headEnd type="none" w="med" len="med"/>
+                      <a:tailEnd type="none" w="med" len="med"/>
+                    </a:lnL>
+                    <a:lnR w="6350" cap="flat" cmpd="sng" algn="ctr">
+                      <a:solidFill>
+                        <a:srgbClr val="E2E8F0"/>
+                      </a:solidFill>
+                      <a:prstDash val="solid"/>
+                      <a:round/>
+                      <a:headEnd type="none" w="med" len="med"/>
+                      <a:tailEnd type="none" w="med" len="med"/>
+                    </a:lnR>
+                    <a:lnT w="6350" cap="flat" cmpd="sng" algn="ctr">
+                      <a:solidFill>
+                        <a:srgbClr val="E2E8F0"/>
+                      </a:solidFill>
+                      <a:prstDash val="solid"/>
+                      <a:round/>
+                      <a:headEnd type="none" w="med" len="med"/>
+                      <a:tailEnd type="none" w="med" len="med"/>
+                    </a:lnT>
+                    <a:lnB w="6350" cap="flat" cmpd="sng" algn="ctr">
+                      <a:solidFill>
+                        <a:srgbClr val="E2E8F0"/>
+                      </a:solidFill>
+                      <a:prstDash val="solid"/>
+                      <a:round/>
+                      <a:headEnd type="none" w="med" len="med"/>
+                      <a:tailEnd type="none" w="med" len="med"/>
+                    </a:lnB>
+                    <a:solidFill>
+                      <a:srgbClr val="FFFFFF"/>
+                    </a:solidFill>
+                  </a:tcPr>
+                </a:tc>
+                <a:tc>
+                  <a:txBody>
+                    <a:bodyPr/>
+                    <a:lstStyle/>
+                    <a:p>
+                      <a:pPr marL="0" indent="0">
+                        <a:buNone/>
+                      </a:pPr>
+                      <a:r>
+                        <a:rPr lang="en-US" sz="800" b="1" dirty="0">
+                          <a:solidFill>
+                            <a:srgbClr val="2A9D8F"/>
+                          </a:solidFill>
+                        </a:rPr>
+                        <a:t>5</a:t>
+                      </a:r>
+                      <a:endParaRPr lang="en-US" sz="800" dirty="0"/>
+                    </a:p>
+                  </a:txBody>
+                  <a:tcPr>
+                    <a:lnL w="6350" cap="flat" cmpd="sng" algn="ctr">
+                      <a:solidFill>
+                        <a:srgbClr val="E2E8F0"/>
+                      </a:solidFill>
+                      <a:prstDash val="solid"/>
+                      <a:round/>
+                      <a:headEnd type="none" w="med" len="med"/>
+                      <a:tailEnd type="none" w="med" len="med"/>
+                    </a:lnL>
+                    <a:lnR w="6350" cap="flat" cmpd="sng" algn="ctr">
+                      <a:solidFill>
+                        <a:srgbClr val="E2E8F0"/>
+                      </a:solidFill>
+                      <a:prstDash val="solid"/>
+                      <a:round/>
+                      <a:headEnd type="none" w="med" len="med"/>
+                      <a:tailEnd type="none" w="med" len="med"/>
+                    </a:lnR>
+                    <a:lnT w="6350" cap="flat" cmpd="sng" algn="ctr">
+                      <a:solidFill>
+                        <a:srgbClr val="E2E8F0"/>
+                      </a:solidFill>
+                      <a:prstDash val="solid"/>
+                      <a:round/>
+                      <a:headEnd type="none" w="med" len="med"/>
+                      <a:tailEnd type="none" w="med" len="med"/>
+                    </a:lnT>
+                    <a:lnB w="6350" cap="flat" cmpd="sng" algn="ctr">
+                      <a:solidFill>
+                        <a:srgbClr val="E2E8F0"/>
+                      </a:solidFill>
+                      <a:prstDash val="solid"/>
+                      <a:round/>
+                      <a:headEnd type="none" w="med" len="med"/>
+                      <a:tailEnd type="none" w="med" len="med"/>
+                    </a:lnB>
+                    <a:solidFill>
+                      <a:srgbClr val="FFFFFF"/>
+                    </a:solidFill>
+                  </a:tcPr>
+                </a:tc>
+                <a:extLst>
+                  <a:ext uri="{0D108BD9-81ED-4DB2-BD59-A6C34878D82A}">
+                    <a16:rowId xmlns:a16="http://schemas.microsoft.com/office/drawing/2014/main" val="1153074418"/>
+                  </a:ext>
+                </a:extLst>
+              </a:tr>
+              <a:tr h="0">
+                <a:tc>
+                  <a:txBody>
+                    <a:bodyPr/>
+                    <a:lstStyle/>
+                    <a:p>
+                      <a:pPr marL="0" indent="0">
+                        <a:buNone/>
+                      </a:pPr>
+                      <a:r>
+                        <a:rPr lang="en-US" sz="800" b="1" dirty="0">
+                          <a:solidFill>
+                            <a:srgbClr val="1B3A5C"/>
+                          </a:solidFill>
+                        </a:rPr>
+                        <a:t>Activity</a:t>
+                      </a:r>
+                      <a:endParaRPr lang="en-US" sz="800" dirty="0"/>
+                    </a:p>
+                  </a:txBody>
+                  <a:tcPr>
+                    <a:lnL w="6350" cap="flat" cmpd="sng" algn="ctr">
+                      <a:solidFill>
+                        <a:srgbClr val="E2E8F0"/>
+                      </a:solidFill>
+                      <a:prstDash val="solid"/>
+                      <a:round/>
+                      <a:headEnd type="none" w="med" len="med"/>
+                      <a:tailEnd type="none" w="med" len="med"/>
+                    </a:lnL>
+                    <a:lnR w="6350" cap="flat" cmpd="sng" algn="ctr">
+                      <a:solidFill>
+                        <a:srgbClr val="E2E8F0"/>
+                      </a:solidFill>
+                      <a:prstDash val="solid"/>
+                      <a:round/>
+                      <a:headEnd type="none" w="med" len="med"/>
+                      <a:tailEnd type="none" w="med" len="med"/>
+                    </a:lnR>
+                    <a:lnT w="6350" cap="flat" cmpd="sng" algn="ctr">
+                      <a:solidFill>
+                        <a:srgbClr val="E2E8F0"/>
+                      </a:solidFill>
+                      <a:prstDash val="solid"/>
+                      <a:round/>
+                      <a:headEnd type="none" w="med" len="med"/>
+                      <a:tailEnd type="none" w="med" len="med"/>
+                    </a:lnT>
+                    <a:lnB w="6350" cap="flat" cmpd="sng" algn="ctr">
+                      <a:solidFill>
+                        <a:srgbClr val="E2E8F0"/>
+                      </a:solidFill>
+                      <a:prstDash val="solid"/>
+                      <a:round/>
+                      <a:headEnd type="none" w="med" len="med"/>
+                      <a:tailEnd type="none" w="med" len="med"/>
+                    </a:lnB>
+                    <a:solidFill>
+                      <a:srgbClr val="FFFFFF"/>
+                    </a:solidFill>
+                  </a:tcPr>
+                </a:tc>
+                <a:tc>
+                  <a:txBody>
+                    <a:bodyPr/>
+                    <a:lstStyle/>
+                    <a:p>
+                      <a:pPr marL="0" indent="0">
+                        <a:buNone/>
+                      </a:pPr>
+                      <a:r>
+                        <a:rPr lang="en-US" sz="800" dirty="0">
+                          <a:solidFill>
+                            <a:srgbClr val="1E293B"/>
+                          </a:solidFill>
+                        </a:rPr>
+                        <a:t>Lookup</a:t>
+                      </a:r>
+                      <a:endParaRPr lang="en-US" sz="800" dirty="0"/>
+                    </a:p>
+                  </a:txBody>
+                  <a:tcPr>
+                    <a:lnL w="6350" cap="flat" cmpd="sng" algn="ctr">
+                      <a:solidFill>
+                        <a:srgbClr val="E2E8F0"/>
+                      </a:solidFill>
+                      <a:prstDash val="solid"/>
+                      <a:round/>
+                      <a:headEnd type="none" w="med" len="med"/>
+                      <a:tailEnd type="none" w="med" len="med"/>
+                    </a:lnL>
+                    <a:lnR w="6350" cap="flat" cmpd="sng" algn="ctr">
+                      <a:solidFill>
+                        <a:srgbClr val="E2E8F0"/>
+                      </a:solidFill>
+                      <a:prstDash val="solid"/>
+                      <a:round/>
+                      <a:headEnd type="none" w="med" len="med"/>
+                      <a:tailEnd type="none" w="med" len="med"/>
+                    </a:lnR>
+                    <a:lnT w="6350" cap="flat" cmpd="sng" algn="ctr">
+                      <a:solidFill>
+                        <a:srgbClr val="E2E8F0"/>
+                      </a:solidFill>
+                      <a:prstDash val="solid"/>
+                      <a:round/>
+                      <a:headEnd type="none" w="med" len="med"/>
+                      <a:tailEnd type="none" w="med" len="med"/>
+                    </a:lnT>
+                    <a:lnB w="6350" cap="flat" cmpd="sng" algn="ctr">
+                      <a:solidFill>
+                        <a:srgbClr val="E2E8F0"/>
+                      </a:solidFill>
+                      <a:prstDash val="solid"/>
+                      <a:round/>
+                      <a:headEnd type="none" w="med" len="med"/>
+                      <a:tailEnd type="none" w="med" len="med"/>
+                    </a:lnB>
+                    <a:solidFill>
+                      <a:srgbClr val="FFFFFF"/>
+                    </a:solidFill>
+                  </a:tcPr>
+                </a:tc>
+                <a:tc>
+                  <a:txBody>
+                    <a:bodyPr/>
+                    <a:lstStyle/>
+                    <a:p>
+                      <a:pPr marL="0" indent="0">
+                        <a:buNone/>
+                      </a:pPr>
+                      <a:r>
+                        <a:rPr lang="en-US" sz="800" dirty="0">
+                          <a:solidFill>
+                            <a:srgbClr val="1E293B"/>
+                          </a:solidFill>
+                        </a:rPr>
+                        <a:t>Business activity sectors (Manufacturing, Service, etc.)</a:t>
+                      </a:r>
+                      <a:endParaRPr lang="en-US" sz="800" dirty="0"/>
+                    </a:p>
+                  </a:txBody>
+                  <a:tcPr>
+                    <a:lnL w="6350" cap="flat" cmpd="sng" algn="ctr">
+                      <a:solidFill>
+                        <a:srgbClr val="E2E8F0"/>
+                      </a:solidFill>
+                      <a:prstDash val="solid"/>
+                      <a:round/>
+                      <a:headEnd type="none" w="med" len="med"/>
+                      <a:tailEnd type="none" w="med" len="med"/>
+                    </a:lnL>
+                    <a:lnR w="6350" cap="flat" cmpd="sng" algn="ctr">
+                      <a:solidFill>
+                        <a:srgbClr val="E2E8F0"/>
+                      </a:solidFill>
+                      <a:prstDash val="solid"/>
+                      <a:round/>
+                      <a:headEnd type="none" w="med" len="med"/>
+                      <a:tailEnd type="none" w="med" len="med"/>
+                    </a:lnR>
+                    <a:lnT w="6350" cap="flat" cmpd="sng" algn="ctr">
+                      <a:solidFill>
+                        <a:srgbClr val="E2E8F0"/>
+                      </a:solidFill>
+                      <a:prstDash val="solid"/>
+                      <a:round/>
+                      <a:headEnd type="none" w="med" len="med"/>
+                      <a:tailEnd type="none" w="med" len="med"/>
+                    </a:lnT>
+                    <a:lnB w="6350" cap="flat" cmpd="sng" algn="ctr">
+                      <a:solidFill>
+                        <a:srgbClr val="E2E8F0"/>
+                      </a:solidFill>
+                      <a:prstDash val="solid"/>
+                      <a:round/>
+                      <a:headEnd type="none" w="med" len="med"/>
+                      <a:tailEnd type="none" w="med" len="med"/>
+                    </a:lnB>
+                    <a:solidFill>
+                      <a:srgbClr val="FFFFFF"/>
+                    </a:solidFill>
+                  </a:tcPr>
+                </a:tc>
+                <a:tc>
+                  <a:txBody>
+                    <a:bodyPr/>
+                    <a:lstStyle/>
+                    <a:p>
+                      <a:pPr marL="0" indent="0">
+                        <a:buNone/>
+                      </a:pPr>
+                      <a:r>
+                        <a:rPr lang="en-US" sz="800" b="1" dirty="0">
+                          <a:solidFill>
+                            <a:srgbClr val="2A9D8F"/>
+                          </a:solidFill>
+                        </a:rPr>
+                        <a:t>5</a:t>
+                      </a:r>
+                      <a:endParaRPr lang="en-US" sz="800" dirty="0"/>
+                    </a:p>
+                  </a:txBody>
+                  <a:tcPr>
+                    <a:lnL w="6350" cap="flat" cmpd="sng" algn="ctr">
+                      <a:solidFill>
+                        <a:srgbClr val="E2E8F0"/>
+                      </a:solidFill>
+                      <a:prstDash val="solid"/>
+                      <a:round/>
+                      <a:headEnd type="none" w="med" len="med"/>
+                      <a:tailEnd type="none" w="med" len="med"/>
+                    </a:lnL>
+                    <a:lnR w="6350" cap="flat" cmpd="sng" algn="ctr">
+                      <a:solidFill>
+                        <a:srgbClr val="E2E8F0"/>
+                      </a:solidFill>
+                      <a:prstDash val="solid"/>
+                      <a:round/>
+                      <a:headEnd type="none" w="med" len="med"/>
+                      <a:tailEnd type="none" w="med" len="med"/>
+                    </a:lnR>
+                    <a:lnT w="6350" cap="flat" cmpd="sng" algn="ctr">
+                      <a:solidFill>
+                        <a:srgbClr val="E2E8F0"/>
+                      </a:solidFill>
+                      <a:prstDash val="solid"/>
+                      <a:round/>
+                      <a:headEnd type="none" w="med" len="med"/>
+                      <a:tailEnd type="none" w="med" len="med"/>
+                    </a:lnT>
+                    <a:lnB w="6350" cap="flat" cmpd="sng" algn="ctr">
+                      <a:solidFill>
+                        <a:srgbClr val="E2E8F0"/>
+                      </a:solidFill>
+                      <a:prstDash val="solid"/>
+                      <a:round/>
+                      <a:headEnd type="none" w="med" len="med"/>
+                      <a:tailEnd type="none" w="med" len="med"/>
+                    </a:lnB>
+                    <a:solidFill>
+                      <a:srgbClr val="FFFFFF"/>
+                    </a:solidFill>
+                  </a:tcPr>
+                </a:tc>
+                <a:extLst>
+                  <a:ext uri="{0D108BD9-81ED-4DB2-BD59-A6C34878D82A}">
+                    <a16:rowId xmlns:a16="http://schemas.microsoft.com/office/drawing/2014/main" val="470788513"/>
+                  </a:ext>
+                </a:extLst>
+              </a:tr>
+              <a:tr h="288963">
                 <a:tc>
                   <a:txBody>
                     <a:bodyPr/>
@@ -16386,7 +15417,7 @@
                             <a:srgbClr val="2A9D8F"/>
                           </a:solidFill>
                         </a:rPr>
-                        <a:t>1,002</a:t>
+                        <a:t>1,000</a:t>
                       </a:r>
                       <a:endParaRPr lang="en-US" sz="800" dirty="0"/>
                     </a:p>
@@ -16439,7 +15470,7 @@
                   </a:ext>
                 </a:extLst>
               </a:tr>
-              <a:tr h="0">
+              <a:tr h="288963">
                 <a:tc>
                   <a:txBody>
                     <a:bodyPr/>
@@ -16690,7 +15721,7 @@
                   </a:ext>
                 </a:extLst>
               </a:tr>
-              <a:tr h="0">
+              <a:tr h="288963">
                 <a:tc>
                   <a:txBody>
                     <a:bodyPr/>
@@ -16705,7 +15736,7 @@
                             <a:srgbClr val="1B3A5C"/>
                           </a:solidFill>
                         </a:rPr>
-                        <a:t>Category</a:t>
+                        <a:t>Owner</a:t>
                       </a:r>
                       <a:endParaRPr lang="en-US" sz="800" dirty="0"/>
                     </a:p>
@@ -16766,7 +15797,7 @@
                             <a:srgbClr val="1E293B"/>
                           </a:solidFill>
                         </a:rPr>
-                        <a:t>Lookup</a:t>
+                        <a:t>Reference</a:t>
                       </a:r>
                       <a:endParaRPr lang="en-US" sz="800" dirty="0"/>
                     </a:p>
@@ -16827,7 +15858,7 @@
                             <a:srgbClr val="1E293B"/>
                           </a:solidFill>
                         </a:rPr>
-                        <a:t>Taxpayer categories (Individual, SME, Corp)</a:t>
+                        <a:t>Business owners with ownership percentages</a:t>
                       </a:r>
                       <a:endParaRPr lang="en-US" sz="800" dirty="0"/>
                     </a:p>
@@ -16888,7 +15919,7 @@
                             <a:srgbClr val="2A9D8F"/>
                           </a:solidFill>
                         </a:rPr>
-                        <a:t>5</a:t>
+                        <a:t>~1,956</a:t>
                       </a:r>
                       <a:endParaRPr lang="en-US" sz="800" dirty="0"/>
                     </a:p>
@@ -16937,11 +15968,11 @@
                 </a:tc>
                 <a:extLst>
                   <a:ext uri="{0D108BD9-81ED-4DB2-BD59-A6C34878D82A}">
-                    <a16:rowId xmlns:a16="http://schemas.microsoft.com/office/drawing/2014/main" val="10003"/>
+                    <a16:rowId xmlns:a16="http://schemas.microsoft.com/office/drawing/2014/main" val="10007"/>
                   </a:ext>
                 </a:extLst>
               </a:tr>
-              <a:tr h="0">
+              <a:tr h="288963">
                 <a:tc>
                   <a:txBody>
                     <a:bodyPr/>
@@ -17192,7 +16223,7 @@
                   </a:ext>
                 </a:extLst>
               </a:tr>
-              <a:tr h="0">
+              <a:tr h="288963">
                 <a:tc>
                   <a:txBody>
                     <a:bodyPr/>
@@ -17443,7 +16474,7 @@
                   </a:ext>
                 </a:extLst>
               </a:tr>
-              <a:tr h="0">
+              <a:tr h="288963">
                 <a:tc>
                   <a:txBody>
                     <a:bodyPr/>
@@ -17694,257 +16725,6 @@
                   </a:ext>
                 </a:extLst>
               </a:tr>
-              <a:tr h="0">
-                <a:tc>
-                  <a:txBody>
-                    <a:bodyPr/>
-                    <a:lstStyle/>
-                    <a:p>
-                      <a:pPr marL="0" indent="0">
-                        <a:buNone/>
-                      </a:pPr>
-                      <a:r>
-                        <a:rPr lang="en-US" sz="800" b="1" dirty="0">
-                          <a:solidFill>
-                            <a:srgbClr val="1B3A5C"/>
-                          </a:solidFill>
-                        </a:rPr>
-                        <a:t>Owner</a:t>
-                      </a:r>
-                      <a:endParaRPr lang="en-US" sz="800" dirty="0"/>
-                    </a:p>
-                  </a:txBody>
-                  <a:tcPr>
-                    <a:lnL w="6350" cap="flat" cmpd="sng" algn="ctr">
-                      <a:solidFill>
-                        <a:srgbClr val="E2E8F0"/>
-                      </a:solidFill>
-                      <a:prstDash val="solid"/>
-                      <a:round/>
-                      <a:headEnd type="none" w="med" len="med"/>
-                      <a:tailEnd type="none" w="med" len="med"/>
-                    </a:lnL>
-                    <a:lnR w="6350" cap="flat" cmpd="sng" algn="ctr">
-                      <a:solidFill>
-                        <a:srgbClr val="E2E8F0"/>
-                      </a:solidFill>
-                      <a:prstDash val="solid"/>
-                      <a:round/>
-                      <a:headEnd type="none" w="med" len="med"/>
-                      <a:tailEnd type="none" w="med" len="med"/>
-                    </a:lnR>
-                    <a:lnT w="6350" cap="flat" cmpd="sng" algn="ctr">
-                      <a:solidFill>
-                        <a:srgbClr val="E2E8F0"/>
-                      </a:solidFill>
-                      <a:prstDash val="solid"/>
-                      <a:round/>
-                      <a:headEnd type="none" w="med" len="med"/>
-                      <a:tailEnd type="none" w="med" len="med"/>
-                    </a:lnT>
-                    <a:lnB w="6350" cap="flat" cmpd="sng" algn="ctr">
-                      <a:solidFill>
-                        <a:srgbClr val="E2E8F0"/>
-                      </a:solidFill>
-                      <a:prstDash val="solid"/>
-                      <a:round/>
-                      <a:headEnd type="none" w="med" len="med"/>
-                      <a:tailEnd type="none" w="med" len="med"/>
-                    </a:lnB>
-                    <a:solidFill>
-                      <a:srgbClr val="FFFFFF"/>
-                    </a:solidFill>
-                  </a:tcPr>
-                </a:tc>
-                <a:tc>
-                  <a:txBody>
-                    <a:bodyPr/>
-                    <a:lstStyle/>
-                    <a:p>
-                      <a:pPr marL="0" indent="0">
-                        <a:buNone/>
-                      </a:pPr>
-                      <a:r>
-                        <a:rPr lang="en-US" sz="800" dirty="0">
-                          <a:solidFill>
-                            <a:srgbClr val="1E293B"/>
-                          </a:solidFill>
-                        </a:rPr>
-                        <a:t>Reference</a:t>
-                      </a:r>
-                      <a:endParaRPr lang="en-US" sz="800" dirty="0"/>
-                    </a:p>
-                  </a:txBody>
-                  <a:tcPr>
-                    <a:lnL w="6350" cap="flat" cmpd="sng" algn="ctr">
-                      <a:solidFill>
-                        <a:srgbClr val="E2E8F0"/>
-                      </a:solidFill>
-                      <a:prstDash val="solid"/>
-                      <a:round/>
-                      <a:headEnd type="none" w="med" len="med"/>
-                      <a:tailEnd type="none" w="med" len="med"/>
-                    </a:lnL>
-                    <a:lnR w="6350" cap="flat" cmpd="sng" algn="ctr">
-                      <a:solidFill>
-                        <a:srgbClr val="E2E8F0"/>
-                      </a:solidFill>
-                      <a:prstDash val="solid"/>
-                      <a:round/>
-                      <a:headEnd type="none" w="med" len="med"/>
-                      <a:tailEnd type="none" w="med" len="med"/>
-                    </a:lnR>
-                    <a:lnT w="6350" cap="flat" cmpd="sng" algn="ctr">
-                      <a:solidFill>
-                        <a:srgbClr val="E2E8F0"/>
-                      </a:solidFill>
-                      <a:prstDash val="solid"/>
-                      <a:round/>
-                      <a:headEnd type="none" w="med" len="med"/>
-                      <a:tailEnd type="none" w="med" len="med"/>
-                    </a:lnT>
-                    <a:lnB w="6350" cap="flat" cmpd="sng" algn="ctr">
-                      <a:solidFill>
-                        <a:srgbClr val="E2E8F0"/>
-                      </a:solidFill>
-                      <a:prstDash val="solid"/>
-                      <a:round/>
-                      <a:headEnd type="none" w="med" len="med"/>
-                      <a:tailEnd type="none" w="med" len="med"/>
-                    </a:lnB>
-                    <a:solidFill>
-                      <a:srgbClr val="FFFFFF"/>
-                    </a:solidFill>
-                  </a:tcPr>
-                </a:tc>
-                <a:tc>
-                  <a:txBody>
-                    <a:bodyPr/>
-                    <a:lstStyle/>
-                    <a:p>
-                      <a:pPr marL="0" indent="0">
-                        <a:buNone/>
-                      </a:pPr>
-                      <a:r>
-                        <a:rPr lang="en-US" sz="800" dirty="0">
-                          <a:solidFill>
-                            <a:srgbClr val="1E293B"/>
-                          </a:solidFill>
-                        </a:rPr>
-                        <a:t>Business owners with ownership percentages</a:t>
-                      </a:r>
-                      <a:endParaRPr lang="en-US" sz="800" dirty="0"/>
-                    </a:p>
-                  </a:txBody>
-                  <a:tcPr>
-                    <a:lnL w="6350" cap="flat" cmpd="sng" algn="ctr">
-                      <a:solidFill>
-                        <a:srgbClr val="E2E8F0"/>
-                      </a:solidFill>
-                      <a:prstDash val="solid"/>
-                      <a:round/>
-                      <a:headEnd type="none" w="med" len="med"/>
-                      <a:tailEnd type="none" w="med" len="med"/>
-                    </a:lnL>
-                    <a:lnR w="6350" cap="flat" cmpd="sng" algn="ctr">
-                      <a:solidFill>
-                        <a:srgbClr val="E2E8F0"/>
-                      </a:solidFill>
-                      <a:prstDash val="solid"/>
-                      <a:round/>
-                      <a:headEnd type="none" w="med" len="med"/>
-                      <a:tailEnd type="none" w="med" len="med"/>
-                    </a:lnR>
-                    <a:lnT w="6350" cap="flat" cmpd="sng" algn="ctr">
-                      <a:solidFill>
-                        <a:srgbClr val="E2E8F0"/>
-                      </a:solidFill>
-                      <a:prstDash val="solid"/>
-                      <a:round/>
-                      <a:headEnd type="none" w="med" len="med"/>
-                      <a:tailEnd type="none" w="med" len="med"/>
-                    </a:lnT>
-                    <a:lnB w="6350" cap="flat" cmpd="sng" algn="ctr">
-                      <a:solidFill>
-                        <a:srgbClr val="E2E8F0"/>
-                      </a:solidFill>
-                      <a:prstDash val="solid"/>
-                      <a:round/>
-                      <a:headEnd type="none" w="med" len="med"/>
-                      <a:tailEnd type="none" w="med" len="med"/>
-                    </a:lnB>
-                    <a:solidFill>
-                      <a:srgbClr val="FFFFFF"/>
-                    </a:solidFill>
-                  </a:tcPr>
-                </a:tc>
-                <a:tc>
-                  <a:txBody>
-                    <a:bodyPr/>
-                    <a:lstStyle/>
-                    <a:p>
-                      <a:pPr marL="0" indent="0">
-                        <a:buNone/>
-                      </a:pPr>
-                      <a:r>
-                        <a:rPr lang="en-US" sz="800" b="1" dirty="0">
-                          <a:solidFill>
-                            <a:srgbClr val="2A9D8F"/>
-                          </a:solidFill>
-                        </a:rPr>
-                        <a:t>~1,956</a:t>
-                      </a:r>
-                      <a:endParaRPr lang="en-US" sz="800" dirty="0"/>
-                    </a:p>
-                  </a:txBody>
-                  <a:tcPr>
-                    <a:lnL w="6350" cap="flat" cmpd="sng" algn="ctr">
-                      <a:solidFill>
-                        <a:srgbClr val="E2E8F0"/>
-                      </a:solidFill>
-                      <a:prstDash val="solid"/>
-                      <a:round/>
-                      <a:headEnd type="none" w="med" len="med"/>
-                      <a:tailEnd type="none" w="med" len="med"/>
-                    </a:lnL>
-                    <a:lnR w="6350" cap="flat" cmpd="sng" algn="ctr">
-                      <a:solidFill>
-                        <a:srgbClr val="E2E8F0"/>
-                      </a:solidFill>
-                      <a:prstDash val="solid"/>
-                      <a:round/>
-                      <a:headEnd type="none" w="med" len="med"/>
-                      <a:tailEnd type="none" w="med" len="med"/>
-                    </a:lnR>
-                    <a:lnT w="6350" cap="flat" cmpd="sng" algn="ctr">
-                      <a:solidFill>
-                        <a:srgbClr val="E2E8F0"/>
-                      </a:solidFill>
-                      <a:prstDash val="solid"/>
-                      <a:round/>
-                      <a:headEnd type="none" w="med" len="med"/>
-                      <a:tailEnd type="none" w="med" len="med"/>
-                    </a:lnT>
-                    <a:lnB w="6350" cap="flat" cmpd="sng" algn="ctr">
-                      <a:solidFill>
-                        <a:srgbClr val="E2E8F0"/>
-                      </a:solidFill>
-                      <a:prstDash val="solid"/>
-                      <a:round/>
-                      <a:headEnd type="none" w="med" len="med"/>
-                      <a:tailEnd type="none" w="med" len="med"/>
-                    </a:lnB>
-                    <a:solidFill>
-                      <a:srgbClr val="FFFFFF"/>
-                    </a:solidFill>
-                  </a:tcPr>
-                </a:tc>
-                <a:extLst>
-                  <a:ext uri="{0D108BD9-81ED-4DB2-BD59-A6C34878D82A}">
-                    <a16:rowId xmlns:a16="http://schemas.microsoft.com/office/drawing/2014/main" val="10007"/>
-                  </a:ext>
-                </a:extLst>
-              </a:tr>
             </a:tbl>
           </a:graphicData>
         </a:graphic>
@@ -17957,7 +16737,7 @@
         </p:nvSpPr>
         <p:spPr>
           <a:xfrm>
-            <a:off x="457200" y="3931920"/>
+            <a:off x="457200" y="4238895"/>
             <a:ext cx="8229600" cy="457200"/>
           </a:xfrm>
           <a:prstGeom prst="rect">
@@ -17979,7 +16759,7 @@
                   <a:srgbClr val="64748B"/>
                 </a:solidFill>
               </a:rPr>
-              <a:t>Data Generator (02_TransactionData.sql): Also includes Structure (5) &amp; Activity (5) lookup tables. 1,000 taxpayers, 4 years (2020–2023), 99.8% filing coverage, 58,813 records. Verified: 10 FKs, 19 CHECK constraints, 37 indexes, 0 orphans, 0 NULLs (see Source Database Verification document).</a:t>
+              <a:t>Data Generator (02_TransactionData.sql): 1,000 taxpayers, 4 years (2020–2023), 99.8% filing coverage, 58,813 records. Verified: 10 FKs, 19 CHECK constraints, 35 indexes, 0 orphans, 0 NULLs (see Source Database Verification document).</a:t>
             </a:r>
             <a:endParaRPr lang="en-US" sz="1000" dirty="0"/>
           </a:p>

</xml_diff>

<commit_message>
Update presentation by remove benchark contents
</commit_message>
<xml_diff>
--- a/Documents/Final_Presentation.pptx
+++ b/Documents/Final_Presentation.pptx
@@ -5824,7 +5824,7 @@
                     <a:srgbClr val="64748B"/>
                   </a:solidFill>
                 </a:rPr>
-                <a:t>Benchmarks, POC Evidence, Key Insights</a:t>
+                <a:t>POC Evidence, 4 Challenges Addressed, Key Insights</a:t>
               </a:r>
               <a:endParaRPr lang="en-US" sz="1050" dirty="0"/>
             </a:p>
@@ -10549,77 +10549,40 @@
           </a:p>
         </p:txBody>
       </p:sp>
-      <p:sp>
-        <p:nvSpPr>
-          <p:cNvPr id="6" name="Shape 4"/>
-          <p:cNvSpPr/>
-          <p:nvPr/>
-        </p:nvSpPr>
-        <p:spPr>
-          <a:xfrm>
-            <a:off x="274320" y="960120"/>
-            <a:ext cx="1508760" cy="1828800"/>
-          </a:xfrm>
-          <a:prstGeom prst="rect">
-            <a:avLst/>
-          </a:prstGeom>
-          <a:solidFill>
-            <a:srgbClr val="FFFFFF"/>
-          </a:solidFill>
-          <a:ln/>
-          <a:effectLst>
-            <a:outerShdw blurRad="50800" dist="25400" dir="8100000" algn="bl" rotWithShape="0">
-              <a:srgbClr val="000000">
-                <a:alpha val="10000"/>
-              </a:srgbClr>
-            </a:outerShdw>
-          </a:effectLst>
-        </p:spPr>
-        <p:txBody>
-          <a:bodyPr/>
-          <a:lstStyle/>
-          <a:p>
-            <a:endParaRPr/>
-          </a:p>
-        </p:txBody>
-      </p:sp>
-      <p:sp>
-        <p:nvSpPr>
-          <p:cNvPr id="7" name="Shape 5"/>
-          <p:cNvSpPr/>
-          <p:nvPr/>
-        </p:nvSpPr>
-        <p:spPr>
-          <a:xfrm>
-            <a:off x="274320" y="960120"/>
-            <a:ext cx="1508760" cy="365760"/>
-          </a:xfrm>
-          <a:prstGeom prst="rect">
-            <a:avLst/>
-          </a:prstGeom>
-          <a:solidFill>
-            <a:srgbClr val="475569"/>
-          </a:solidFill>
-          <a:ln/>
-        </p:spPr>
-        <p:txBody>
-          <a:bodyPr/>
-          <a:lstStyle/>
-          <a:p>
-            <a:endParaRPr/>
-          </a:p>
-        </p:txBody>
-      </p:sp>
-      <p:sp>
-        <p:nvSpPr>
-          <p:cNvPr id="8" name="Text 6"/>
-          <p:cNvSpPr/>
-          <p:nvPr/>
-        </p:nvSpPr>
-        <p:spPr>
-          <a:xfrm>
-            <a:off x="274320" y="960120"/>
-            <a:ext cx="1508760" cy="365760"/>
+      <p:pic>
+        <p:nvPicPr>
+          <p:cNvPr id="100" name="Figure 3.1"/>
+          <p:cNvPicPr>
+            <a:picLocks noChangeAspect="1"/>
+          </p:cNvPicPr>
+          <p:nvPr/>
+        </p:nvPicPr>
+        <p:blipFill>
+          <a:blip r:embed="rId3"/>
+          <a:stretch>
+            <a:fillRect/>
+          </a:stretch>
+        </p:blipFill>
+        <p:spPr>
+          <a:xfrm>
+            <a:off x="350000" y="830000"/>
+            <a:ext cx="8450000" cy="3780000"/>
+          </a:xfrm>
+          <a:prstGeom prst="rect">
+            <a:avLst/>
+          </a:prstGeom>
+        </p:spPr>
+      </p:pic>
+      <p:sp>
+        <p:nvSpPr>
+          <p:cNvPr id="101" name="Caption"/>
+          <p:cNvSpPr/>
+          <p:nvPr/>
+        </p:nvSpPr>
+        <p:spPr>
+          <a:xfrm>
+            <a:off x="457200" y="4650000"/>
+            <a:ext cx="8229600" cy="274320"/>
           </a:xfrm>
           <a:prstGeom prst="rect">
             <a:avLst/>
@@ -10628,1427 +10591,29 @@
           <a:ln/>
         </p:spPr>
         <p:txBody>
-          <a:bodyPr wrap="square" rtlCol="0" anchor="ctr"/>
+          <a:bodyPr wrap="square" rtlCol="0" anchor="t"/>
           <a:lstStyle/>
           <a:p>
             <a:pPr marL="0" indent="0" algn="ctr">
               <a:buNone/>
             </a:pPr>
             <a:r>
-              <a:rPr lang="en-US" sz="1100" b="1" dirty="0">
-                <a:solidFill>
-                  <a:srgbClr val="FFFFFF"/>
-                </a:solidFill>
-              </a:rPr>
-              <a:t>Source</a:t>
-            </a:r>
-            <a:endParaRPr lang="en-US" sz="1100" dirty="0"/>
-          </a:p>
-        </p:txBody>
-      </p:sp>
-      <p:sp>
-        <p:nvSpPr>
-          <p:cNvPr id="9" name="Text 7"/>
-          <p:cNvSpPr/>
-          <p:nvPr/>
-        </p:nvSpPr>
-        <p:spPr>
-          <a:xfrm>
-            <a:off x="274320" y="1371600"/>
-            <a:ext cx="1508760" cy="274320"/>
-          </a:xfrm>
-          <a:prstGeom prst="rect">
-            <a:avLst/>
-          </a:prstGeom>
-          <a:noFill/>
-          <a:ln/>
-        </p:spPr>
-        <p:txBody>
-          <a:bodyPr wrap="square" rtlCol="0" anchor="ctr"/>
-          <a:lstStyle/>
-          <a:p>
-            <a:pPr marL="0" indent="0" algn="ctr">
-              <a:buNone/>
-            </a:pPr>
-            <a:r>
-              <a:rPr lang="en-US" sz="850" b="1" dirty="0">
+              <a:rPr lang="en-US" sz="900" b="1" dirty="0">
                 <a:solidFill>
                   <a:srgbClr val="1B3A5C"/>
                 </a:solidFill>
+                <a:latin typeface="Calibri"/>
               </a:rPr>
-              <a:t>TaxSystemDB</a:t>
+              <a:t xml:space="preserve">Figure 3.1: </a:t>
             </a:r>
-            <a:endParaRPr lang="en-US" sz="850" dirty="0"/>
-          </a:p>
-        </p:txBody>
-      </p:sp>
-      <p:sp>
-        <p:nvSpPr>
-          <p:cNvPr id="10" name="Text 8"/>
-          <p:cNvSpPr/>
-          <p:nvPr/>
-        </p:nvSpPr>
-        <p:spPr>
-          <a:xfrm>
-            <a:off x="320040" y="1691640"/>
-            <a:ext cx="1417320" cy="914400"/>
-          </a:xfrm>
-          <a:prstGeom prst="rect">
-            <a:avLst/>
-          </a:prstGeom>
-          <a:noFill/>
-          <a:ln/>
-        </p:spPr>
-        <p:txBody>
-          <a:bodyPr wrap="square" rtlCol="0" anchor="t"/>
-          <a:lstStyle/>
-          <a:p>
-            <a:pPr marL="0" indent="0" algn="ctr">
-              <a:buNone/>
-            </a:pPr>
             <a:r>
-              <a:rPr lang="en-US" sz="850" dirty="0">
+              <a:rPr lang="en-US" sz="900" dirty="0">
                 <a:solidFill>
                   <a:srgbClr val="64748B"/>
                 </a:solidFill>
+                <a:latin typeface="Calibri"/>
               </a:rPr>
-              <a:t>9 tables</a:t>
-            </a:r>
-            <a:endParaRPr lang="en-US" sz="850" dirty="0"/>
-          </a:p>
-          <a:p>
-            <a:pPr marL="0" indent="0" algn="ctr">
-              <a:buNone/>
-            </a:pPr>
-            <a:r>
-              <a:rPr lang="en-US" sz="850" dirty="0">
-                <a:solidFill>
-                  <a:srgbClr val="64748B"/>
-                </a:solidFill>
-              </a:rPr>
-              <a:t>+ 3 lookups</a:t>
-            </a:r>
-            <a:endParaRPr lang="en-US" sz="850" dirty="0"/>
-          </a:p>
-        </p:txBody>
-      </p:sp>
-      <p:sp>
-        <p:nvSpPr>
-          <p:cNvPr id="11" name="Shape 9"/>
-          <p:cNvSpPr/>
-          <p:nvPr/>
-        </p:nvSpPr>
-        <p:spPr>
-          <a:xfrm>
-            <a:off x="1965960" y="960120"/>
-            <a:ext cx="1508760" cy="1828800"/>
-          </a:xfrm>
-          <a:prstGeom prst="rect">
-            <a:avLst/>
-          </a:prstGeom>
-          <a:solidFill>
-            <a:srgbClr val="FFFFFF"/>
-          </a:solidFill>
-          <a:ln/>
-          <a:effectLst>
-            <a:outerShdw blurRad="50800" dist="25400" dir="8100000" algn="bl" rotWithShape="0">
-              <a:srgbClr val="000000">
-                <a:alpha val="10000"/>
-              </a:srgbClr>
-            </a:outerShdw>
-          </a:effectLst>
-        </p:spPr>
-        <p:txBody>
-          <a:bodyPr/>
-          <a:lstStyle/>
-          <a:p>
-            <a:endParaRPr/>
-          </a:p>
-        </p:txBody>
-      </p:sp>
-      <p:sp>
-        <p:nvSpPr>
-          <p:cNvPr id="12" name="Shape 10"/>
-          <p:cNvSpPr/>
-          <p:nvPr/>
-        </p:nvSpPr>
-        <p:spPr>
-          <a:xfrm>
-            <a:off x="1965960" y="960120"/>
-            <a:ext cx="1508760" cy="365760"/>
-          </a:xfrm>
-          <a:prstGeom prst="rect">
-            <a:avLst/>
-          </a:prstGeom>
-          <a:solidFill>
-            <a:srgbClr val="94A3B8"/>
-          </a:solidFill>
-          <a:ln/>
-        </p:spPr>
-        <p:txBody>
-          <a:bodyPr/>
-          <a:lstStyle/>
-          <a:p>
-            <a:endParaRPr/>
-          </a:p>
-        </p:txBody>
-      </p:sp>
-      <p:sp>
-        <p:nvSpPr>
-          <p:cNvPr id="13" name="Text 11"/>
-          <p:cNvSpPr/>
-          <p:nvPr/>
-        </p:nvSpPr>
-        <p:spPr>
-          <a:xfrm>
-            <a:off x="1965960" y="960120"/>
-            <a:ext cx="1508760" cy="365760"/>
-          </a:xfrm>
-          <a:prstGeom prst="rect">
-            <a:avLst/>
-          </a:prstGeom>
-          <a:noFill/>
-          <a:ln/>
-        </p:spPr>
-        <p:txBody>
-          <a:bodyPr wrap="square" rtlCol="0" anchor="ctr"/>
-          <a:lstStyle/>
-          <a:p>
-            <a:pPr marL="0" indent="0" algn="ctr">
-              <a:buNone/>
-            </a:pPr>
-            <a:r>
-              <a:rPr lang="en-US" sz="1100" b="1" dirty="0">
-                <a:solidFill>
-                  <a:srgbClr val="FFFFFF"/>
-                </a:solidFill>
-              </a:rPr>
-              <a:t>Staging</a:t>
-            </a:r>
-            <a:endParaRPr lang="en-US" sz="1100" dirty="0"/>
-          </a:p>
-        </p:txBody>
-      </p:sp>
-      <p:sp>
-        <p:nvSpPr>
-          <p:cNvPr id="14" name="Text 12"/>
-          <p:cNvSpPr/>
-          <p:nvPr/>
-        </p:nvSpPr>
-        <p:spPr>
-          <a:xfrm>
-            <a:off x="1965960" y="1371600"/>
-            <a:ext cx="1508760" cy="274320"/>
-          </a:xfrm>
-          <a:prstGeom prst="rect">
-            <a:avLst/>
-          </a:prstGeom>
-          <a:noFill/>
-          <a:ln/>
-        </p:spPr>
-        <p:txBody>
-          <a:bodyPr wrap="square" rtlCol="0" anchor="ctr"/>
-          <a:lstStyle/>
-          <a:p>
-            <a:pPr marL="0" indent="0" algn="ctr">
-              <a:buNone/>
-            </a:pPr>
-            <a:r>
-              <a:rPr lang="en-US" sz="850" b="1" dirty="0">
-                <a:solidFill>
-                  <a:srgbClr val="1B3A5C"/>
-                </a:solidFill>
-              </a:rPr>
-              <a:t>DV_Staging</a:t>
-            </a:r>
-            <a:endParaRPr lang="en-US" sz="850" dirty="0"/>
-          </a:p>
-        </p:txBody>
-      </p:sp>
-      <p:sp>
-        <p:nvSpPr>
-          <p:cNvPr id="15" name="Text 13"/>
-          <p:cNvSpPr/>
-          <p:nvPr/>
-        </p:nvSpPr>
-        <p:spPr>
-          <a:xfrm>
-            <a:off x="2011680" y="1691640"/>
-            <a:ext cx="1417320" cy="914400"/>
-          </a:xfrm>
-          <a:prstGeom prst="rect">
-            <a:avLst/>
-          </a:prstGeom>
-          <a:noFill/>
-          <a:ln/>
-        </p:spPr>
-        <p:txBody>
-          <a:bodyPr wrap="square" rtlCol="0" anchor="t"/>
-          <a:lstStyle/>
-          <a:p>
-            <a:pPr marL="0" indent="0" algn="ctr">
-              <a:buNone/>
-            </a:pPr>
-            <a:r>
-              <a:rPr lang="en-US" sz="850" dirty="0">
-                <a:solidFill>
-                  <a:srgbClr val="64748B"/>
-                </a:solidFill>
-              </a:rPr>
-              <a:t>9 STG</a:t>
-            </a:r>
-            <a:endParaRPr lang="en-US" sz="850" dirty="0"/>
-          </a:p>
-          <a:p>
-            <a:pPr marL="0" indent="0" algn="ctr">
-              <a:buNone/>
-            </a:pPr>
-            <a:r>
-              <a:rPr lang="en-US" sz="850" dirty="0">
-                <a:solidFill>
-                  <a:srgbClr val="64748B"/>
-                </a:solidFill>
-              </a:rPr>
-              <a:t>tables</a:t>
-            </a:r>
-            <a:endParaRPr lang="en-US" sz="850" dirty="0"/>
-          </a:p>
-        </p:txBody>
-      </p:sp>
-      <p:sp>
-        <p:nvSpPr>
-          <p:cNvPr id="16" name="Shape 14"/>
-          <p:cNvSpPr/>
-          <p:nvPr/>
-        </p:nvSpPr>
-        <p:spPr>
-          <a:xfrm>
-            <a:off x="3657600" y="960120"/>
-            <a:ext cx="1508760" cy="1828800"/>
-          </a:xfrm>
-          <a:prstGeom prst="rect">
-            <a:avLst/>
-          </a:prstGeom>
-          <a:solidFill>
-            <a:srgbClr val="FFFFFF"/>
-          </a:solidFill>
-          <a:ln/>
-          <a:effectLst>
-            <a:outerShdw blurRad="50800" dist="25400" dir="8100000" algn="bl" rotWithShape="0">
-              <a:srgbClr val="000000">
-                <a:alpha val="10000"/>
-              </a:srgbClr>
-            </a:outerShdw>
-          </a:effectLst>
-        </p:spPr>
-        <p:txBody>
-          <a:bodyPr/>
-          <a:lstStyle/>
-          <a:p>
-            <a:endParaRPr/>
-          </a:p>
-        </p:txBody>
-      </p:sp>
-      <p:sp>
-        <p:nvSpPr>
-          <p:cNvPr id="17" name="Shape 15"/>
-          <p:cNvSpPr/>
-          <p:nvPr/>
-        </p:nvSpPr>
-        <p:spPr>
-          <a:xfrm>
-            <a:off x="3657600" y="960120"/>
-            <a:ext cx="1508760" cy="365760"/>
-          </a:xfrm>
-          <a:prstGeom prst="rect">
-            <a:avLst/>
-          </a:prstGeom>
-          <a:solidFill>
-            <a:srgbClr val="CD7F32"/>
-          </a:solidFill>
-          <a:ln/>
-        </p:spPr>
-        <p:txBody>
-          <a:bodyPr/>
-          <a:lstStyle/>
-          <a:p>
-            <a:endParaRPr/>
-          </a:p>
-        </p:txBody>
-      </p:sp>
-      <p:sp>
-        <p:nvSpPr>
-          <p:cNvPr id="18" name="Text 16"/>
-          <p:cNvSpPr/>
-          <p:nvPr/>
-        </p:nvSpPr>
-        <p:spPr>
-          <a:xfrm>
-            <a:off x="3657600" y="960120"/>
-            <a:ext cx="1508760" cy="365760"/>
-          </a:xfrm>
-          <a:prstGeom prst="rect">
-            <a:avLst/>
-          </a:prstGeom>
-          <a:noFill/>
-          <a:ln/>
-        </p:spPr>
-        <p:txBody>
-          <a:bodyPr wrap="square" rtlCol="0" anchor="ctr"/>
-          <a:lstStyle/>
-          <a:p>
-            <a:pPr marL="0" indent="0" algn="ctr">
-              <a:buNone/>
-            </a:pPr>
-            <a:r>
-              <a:rPr lang="en-US" sz="1100" b="1" dirty="0">
-                <a:solidFill>
-                  <a:srgbClr val="FFFFFF"/>
-                </a:solidFill>
-              </a:rPr>
-              <a:t>Bronze</a:t>
-            </a:r>
-            <a:endParaRPr lang="en-US" sz="1100" dirty="0"/>
-          </a:p>
-        </p:txBody>
-      </p:sp>
-      <p:sp>
-        <p:nvSpPr>
-          <p:cNvPr id="19" name="Text 17"/>
-          <p:cNvSpPr/>
-          <p:nvPr/>
-        </p:nvSpPr>
-        <p:spPr>
-          <a:xfrm>
-            <a:off x="3657600" y="1371600"/>
-            <a:ext cx="1508760" cy="274320"/>
-          </a:xfrm>
-          <a:prstGeom prst="rect">
-            <a:avLst/>
-          </a:prstGeom>
-          <a:noFill/>
-          <a:ln/>
-        </p:spPr>
-        <p:txBody>
-          <a:bodyPr wrap="square" rtlCol="0" anchor="ctr"/>
-          <a:lstStyle/>
-          <a:p>
-            <a:pPr marL="0" indent="0" algn="ctr">
-              <a:buNone/>
-            </a:pPr>
-            <a:r>
-              <a:rPr lang="en-US" sz="850" b="1" dirty="0">
-                <a:solidFill>
-                  <a:srgbClr val="1B3A5C"/>
-                </a:solidFill>
-              </a:rPr>
-              <a:t>DV_Bronze</a:t>
-            </a:r>
-            <a:endParaRPr lang="en-US" sz="850" dirty="0"/>
-          </a:p>
-        </p:txBody>
-      </p:sp>
-      <p:sp>
-        <p:nvSpPr>
-          <p:cNvPr id="20" name="Text 18"/>
-          <p:cNvSpPr/>
-          <p:nvPr/>
-        </p:nvSpPr>
-        <p:spPr>
-          <a:xfrm>
-            <a:off x="3703320" y="1691640"/>
-            <a:ext cx="1417320" cy="914400"/>
-          </a:xfrm>
-          <a:prstGeom prst="rect">
-            <a:avLst/>
-          </a:prstGeom>
-          <a:noFill/>
-          <a:ln/>
-        </p:spPr>
-        <p:txBody>
-          <a:bodyPr wrap="square" rtlCol="0" anchor="t"/>
-          <a:lstStyle/>
-          <a:p>
-            <a:pPr marL="0" indent="0" algn="ctr">
-              <a:buNone/>
-            </a:pPr>
-            <a:r>
-              <a:rPr lang="en-US" sz="850" dirty="0">
-                <a:solidFill>
-                  <a:srgbClr val="64748B"/>
-                </a:solidFill>
-              </a:rPr>
-              <a:t>9 Hub</a:t>
-            </a:r>
-            <a:endParaRPr lang="en-US" sz="850" dirty="0"/>
-          </a:p>
-          <a:p>
-            <a:pPr marL="0" indent="0" algn="ctr">
-              <a:buNone/>
-            </a:pPr>
-            <a:r>
-              <a:rPr lang="en-US" sz="850" dirty="0">
-                <a:solidFill>
-                  <a:srgbClr val="64748B"/>
-                </a:solidFill>
-              </a:rPr>
-              <a:t>9 SAT</a:t>
-            </a:r>
-            <a:endParaRPr lang="en-US" sz="850" dirty="0"/>
-          </a:p>
-          <a:p>
-            <a:pPr marL="0" indent="0" algn="ctr">
-              <a:buNone/>
-            </a:pPr>
-            <a:r>
-              <a:rPr lang="en-US" sz="850" dirty="0">
-                <a:solidFill>
-                  <a:srgbClr val="64748B"/>
-                </a:solidFill>
-              </a:rPr>
-              <a:t>5 Link</a:t>
-            </a:r>
-            <a:endParaRPr lang="en-US" sz="850" dirty="0"/>
-          </a:p>
-        </p:txBody>
-      </p:sp>
-      <p:sp>
-        <p:nvSpPr>
-          <p:cNvPr id="21" name="Shape 19"/>
-          <p:cNvSpPr/>
-          <p:nvPr/>
-        </p:nvSpPr>
-        <p:spPr>
-          <a:xfrm>
-            <a:off x="5349240" y="960120"/>
-            <a:ext cx="1508760" cy="1828800"/>
-          </a:xfrm>
-          <a:prstGeom prst="rect">
-            <a:avLst/>
-          </a:prstGeom>
-          <a:solidFill>
-            <a:srgbClr val="FFFFFF"/>
-          </a:solidFill>
-          <a:ln/>
-          <a:effectLst>
-            <a:outerShdw blurRad="50800" dist="25400" dir="8100000" algn="bl" rotWithShape="0">
-              <a:srgbClr val="000000">
-                <a:alpha val="10000"/>
-              </a:srgbClr>
-            </a:outerShdw>
-          </a:effectLst>
-        </p:spPr>
-        <p:txBody>
-          <a:bodyPr/>
-          <a:lstStyle/>
-          <a:p>
-            <a:endParaRPr/>
-          </a:p>
-        </p:txBody>
-      </p:sp>
-      <p:sp>
-        <p:nvSpPr>
-          <p:cNvPr id="22" name="Shape 20"/>
-          <p:cNvSpPr/>
-          <p:nvPr/>
-        </p:nvSpPr>
-        <p:spPr>
-          <a:xfrm>
-            <a:off x="5349240" y="960120"/>
-            <a:ext cx="1508760" cy="365760"/>
-          </a:xfrm>
-          <a:prstGeom prst="rect">
-            <a:avLst/>
-          </a:prstGeom>
-          <a:solidFill>
-            <a:srgbClr val="A8A8A8"/>
-          </a:solidFill>
-          <a:ln/>
-        </p:spPr>
-        <p:txBody>
-          <a:bodyPr/>
-          <a:lstStyle/>
-          <a:p>
-            <a:endParaRPr/>
-          </a:p>
-        </p:txBody>
-      </p:sp>
-      <p:sp>
-        <p:nvSpPr>
-          <p:cNvPr id="23" name="Text 21"/>
-          <p:cNvSpPr/>
-          <p:nvPr/>
-        </p:nvSpPr>
-        <p:spPr>
-          <a:xfrm>
-            <a:off x="5349240" y="960120"/>
-            <a:ext cx="1508760" cy="365760"/>
-          </a:xfrm>
-          <a:prstGeom prst="rect">
-            <a:avLst/>
-          </a:prstGeom>
-          <a:noFill/>
-          <a:ln/>
-        </p:spPr>
-        <p:txBody>
-          <a:bodyPr wrap="square" rtlCol="0" anchor="ctr"/>
-          <a:lstStyle/>
-          <a:p>
-            <a:pPr marL="0" indent="0" algn="ctr">
-              <a:buNone/>
-            </a:pPr>
-            <a:r>
-              <a:rPr lang="en-US" sz="1100" b="1" dirty="0">
-                <a:solidFill>
-                  <a:srgbClr val="FFFFFF"/>
-                </a:solidFill>
-              </a:rPr>
-              <a:t>Silver</a:t>
-            </a:r>
-            <a:endParaRPr lang="en-US" sz="1100" dirty="0"/>
-          </a:p>
-        </p:txBody>
-      </p:sp>
-      <p:sp>
-        <p:nvSpPr>
-          <p:cNvPr id="24" name="Text 22"/>
-          <p:cNvSpPr/>
-          <p:nvPr/>
-        </p:nvSpPr>
-        <p:spPr>
-          <a:xfrm>
-            <a:off x="5349240" y="1371600"/>
-            <a:ext cx="1508760" cy="274320"/>
-          </a:xfrm>
-          <a:prstGeom prst="rect">
-            <a:avLst/>
-          </a:prstGeom>
-          <a:noFill/>
-          <a:ln/>
-        </p:spPr>
-        <p:txBody>
-          <a:bodyPr wrap="square" rtlCol="0" anchor="ctr"/>
-          <a:lstStyle/>
-          <a:p>
-            <a:pPr marL="0" indent="0" algn="ctr">
-              <a:buNone/>
-            </a:pPr>
-            <a:r>
-              <a:rPr lang="en-US" sz="850" b="1" dirty="0">
-                <a:solidFill>
-                  <a:srgbClr val="1B3A5C"/>
-                </a:solidFill>
-              </a:rPr>
-              <a:t>DV_Silver</a:t>
-            </a:r>
-            <a:endParaRPr lang="en-US" sz="850" dirty="0"/>
-          </a:p>
-        </p:txBody>
-      </p:sp>
-      <p:sp>
-        <p:nvSpPr>
-          <p:cNvPr id="25" name="Text 23"/>
-          <p:cNvSpPr/>
-          <p:nvPr/>
-        </p:nvSpPr>
-        <p:spPr>
-          <a:xfrm>
-            <a:off x="5394960" y="1691640"/>
-            <a:ext cx="1417320" cy="914400"/>
-          </a:xfrm>
-          <a:prstGeom prst="rect">
-            <a:avLst/>
-          </a:prstGeom>
-          <a:noFill/>
-          <a:ln/>
-        </p:spPr>
-        <p:txBody>
-          <a:bodyPr wrap="square" rtlCol="0" anchor="t"/>
-          <a:lstStyle/>
-          <a:p>
-            <a:pPr marL="0" indent="0" algn="ctr">
-              <a:buNone/>
-            </a:pPr>
-            <a:r>
-              <a:rPr lang="en-US" sz="850" dirty="0">
-                <a:solidFill>
-                  <a:srgbClr val="64748B"/>
-                </a:solidFill>
-              </a:rPr>
-              <a:t>3 PIT</a:t>
-            </a:r>
-            <a:endParaRPr lang="en-US" sz="850" dirty="0"/>
-          </a:p>
-          <a:p>
-            <a:pPr marL="0" indent="0" algn="ctr">
-              <a:buNone/>
-            </a:pPr>
-            <a:r>
-              <a:rPr lang="en-US" sz="850" dirty="0">
-                <a:solidFill>
-                  <a:srgbClr val="64748B"/>
-                </a:solidFill>
-              </a:rPr>
-              <a:t>1 BRG</a:t>
-            </a:r>
-            <a:endParaRPr lang="en-US" sz="850" dirty="0"/>
-          </a:p>
-          <a:p>
-            <a:pPr marL="0" indent="0" algn="ctr">
-              <a:buNone/>
-            </a:pPr>
-            <a:r>
-              <a:rPr lang="en-US" sz="850" dirty="0">
-                <a:solidFill>
-                  <a:srgbClr val="64748B"/>
-                </a:solidFill>
-              </a:rPr>
-              <a:t>2 BUS</a:t>
-            </a:r>
-            <a:endParaRPr lang="en-US" sz="850" dirty="0"/>
-          </a:p>
-        </p:txBody>
-      </p:sp>
-      <p:sp>
-        <p:nvSpPr>
-          <p:cNvPr id="26" name="Shape 24"/>
-          <p:cNvSpPr/>
-          <p:nvPr/>
-        </p:nvSpPr>
-        <p:spPr>
-          <a:xfrm>
-            <a:off x="7040880" y="960120"/>
-            <a:ext cx="1508760" cy="1828800"/>
-          </a:xfrm>
-          <a:prstGeom prst="rect">
-            <a:avLst/>
-          </a:prstGeom>
-          <a:solidFill>
-            <a:srgbClr val="FFFFFF"/>
-          </a:solidFill>
-          <a:ln/>
-          <a:effectLst>
-            <a:outerShdw blurRad="50800" dist="25400" dir="8100000" algn="bl" rotWithShape="0">
-              <a:srgbClr val="000000">
-                <a:alpha val="10000"/>
-              </a:srgbClr>
-            </a:outerShdw>
-          </a:effectLst>
-        </p:spPr>
-        <p:txBody>
-          <a:bodyPr/>
-          <a:lstStyle/>
-          <a:p>
-            <a:endParaRPr/>
-          </a:p>
-        </p:txBody>
-      </p:sp>
-      <p:sp>
-        <p:nvSpPr>
-          <p:cNvPr id="27" name="Shape 25"/>
-          <p:cNvSpPr/>
-          <p:nvPr/>
-        </p:nvSpPr>
-        <p:spPr>
-          <a:xfrm>
-            <a:off x="7040880" y="960120"/>
-            <a:ext cx="1508760" cy="365760"/>
-          </a:xfrm>
-          <a:prstGeom prst="rect">
-            <a:avLst/>
-          </a:prstGeom>
-          <a:solidFill>
-            <a:srgbClr val="D4A843"/>
-          </a:solidFill>
-          <a:ln/>
-        </p:spPr>
-        <p:txBody>
-          <a:bodyPr/>
-          <a:lstStyle/>
-          <a:p>
-            <a:endParaRPr/>
-          </a:p>
-        </p:txBody>
-      </p:sp>
-      <p:sp>
-        <p:nvSpPr>
-          <p:cNvPr id="28" name="Text 26"/>
-          <p:cNvSpPr/>
-          <p:nvPr/>
-        </p:nvSpPr>
-        <p:spPr>
-          <a:xfrm>
-            <a:off x="7040880" y="960120"/>
-            <a:ext cx="1508760" cy="365760"/>
-          </a:xfrm>
-          <a:prstGeom prst="rect">
-            <a:avLst/>
-          </a:prstGeom>
-          <a:noFill/>
-          <a:ln/>
-        </p:spPr>
-        <p:txBody>
-          <a:bodyPr wrap="square" rtlCol="0" anchor="ctr"/>
-          <a:lstStyle/>
-          <a:p>
-            <a:pPr marL="0" indent="0" algn="ctr">
-              <a:buNone/>
-            </a:pPr>
-            <a:r>
-              <a:rPr lang="en-US" sz="1100" b="1" dirty="0">
-                <a:solidFill>
-                  <a:srgbClr val="FFFFFF"/>
-                </a:solidFill>
-              </a:rPr>
-              <a:t>Gold</a:t>
-            </a:r>
-            <a:endParaRPr lang="en-US" sz="1100" dirty="0"/>
-          </a:p>
-        </p:txBody>
-      </p:sp>
-      <p:sp>
-        <p:nvSpPr>
-          <p:cNvPr id="29" name="Text 27"/>
-          <p:cNvSpPr/>
-          <p:nvPr/>
-        </p:nvSpPr>
-        <p:spPr>
-          <a:xfrm>
-            <a:off x="7040880" y="1371600"/>
-            <a:ext cx="1508760" cy="274320"/>
-          </a:xfrm>
-          <a:prstGeom prst="rect">
-            <a:avLst/>
-          </a:prstGeom>
-          <a:noFill/>
-          <a:ln/>
-        </p:spPr>
-        <p:txBody>
-          <a:bodyPr wrap="square" rtlCol="0" anchor="ctr"/>
-          <a:lstStyle/>
-          <a:p>
-            <a:pPr marL="0" indent="0" algn="ctr">
-              <a:buNone/>
-            </a:pPr>
-            <a:r>
-              <a:rPr lang="en-US" sz="850" b="1" dirty="0">
-                <a:solidFill>
-                  <a:srgbClr val="1B3A5C"/>
-                </a:solidFill>
-              </a:rPr>
-              <a:t>DV_Gold</a:t>
-            </a:r>
-            <a:endParaRPr lang="en-US" sz="850" dirty="0"/>
-          </a:p>
-        </p:txBody>
-      </p:sp>
-      <p:sp>
-        <p:nvSpPr>
-          <p:cNvPr id="30" name="Text 28"/>
-          <p:cNvSpPr/>
-          <p:nvPr/>
-        </p:nvSpPr>
-        <p:spPr>
-          <a:xfrm>
-            <a:off x="7086600" y="1691640"/>
-            <a:ext cx="1417320" cy="914400"/>
-          </a:xfrm>
-          <a:prstGeom prst="rect">
-            <a:avLst/>
-          </a:prstGeom>
-          <a:noFill/>
-          <a:ln/>
-        </p:spPr>
-        <p:txBody>
-          <a:bodyPr wrap="square" rtlCol="0" anchor="t"/>
-          <a:lstStyle/>
-          <a:p>
-            <a:pPr marL="0" indent="0" algn="ctr">
-              <a:buNone/>
-            </a:pPr>
-            <a:r>
-              <a:rPr lang="en-US" sz="850" dirty="0">
-                <a:solidFill>
-                  <a:srgbClr val="64748B"/>
-                </a:solidFill>
-              </a:rPr>
-              <a:t>7 DIM</a:t>
-            </a:r>
-            <a:endParaRPr lang="en-US" sz="850" dirty="0"/>
-          </a:p>
-          <a:p>
-            <a:pPr marL="0" indent="0" algn="ctr">
-              <a:buNone/>
-            </a:pPr>
-            <a:r>
-              <a:rPr lang="en-US" sz="850" dirty="0">
-                <a:solidFill>
-                  <a:srgbClr val="64748B"/>
-                </a:solidFill>
-              </a:rPr>
-              <a:t>4 FACT</a:t>
-            </a:r>
-            <a:endParaRPr lang="en-US" sz="850" dirty="0"/>
-          </a:p>
-        </p:txBody>
-      </p:sp>
-      <p:sp>
-        <p:nvSpPr>
-          <p:cNvPr id="31" name="Text 29"/>
-          <p:cNvSpPr/>
-          <p:nvPr/>
-        </p:nvSpPr>
-        <p:spPr>
-          <a:xfrm>
-            <a:off x="1737360" y="1508760"/>
-            <a:ext cx="274320" cy="365760"/>
-          </a:xfrm>
-          <a:prstGeom prst="rect">
-            <a:avLst/>
-          </a:prstGeom>
-          <a:noFill/>
-          <a:ln/>
-        </p:spPr>
-        <p:txBody>
-          <a:bodyPr wrap="square" rtlCol="0" anchor="ctr"/>
-          <a:lstStyle/>
-          <a:p>
-            <a:pPr marL="0" indent="0" algn="ctr">
-              <a:buNone/>
-            </a:pPr>
-            <a:r>
-              <a:rPr lang="en-US" sz="1800" dirty="0">
-                <a:solidFill>
-                  <a:srgbClr val="2A9D8F"/>
-                </a:solidFill>
-              </a:rPr>
-              <a:t>→</a:t>
-            </a:r>
-            <a:endParaRPr lang="en-US" sz="1800" dirty="0"/>
-          </a:p>
-        </p:txBody>
-      </p:sp>
-      <p:sp>
-        <p:nvSpPr>
-          <p:cNvPr id="32" name="Text 30"/>
-          <p:cNvSpPr/>
-          <p:nvPr/>
-        </p:nvSpPr>
-        <p:spPr>
-          <a:xfrm>
-            <a:off x="3429000" y="1508760"/>
-            <a:ext cx="274320" cy="365760"/>
-          </a:xfrm>
-          <a:prstGeom prst="rect">
-            <a:avLst/>
-          </a:prstGeom>
-          <a:noFill/>
-          <a:ln/>
-        </p:spPr>
-        <p:txBody>
-          <a:bodyPr wrap="square" rtlCol="0" anchor="ctr"/>
-          <a:lstStyle/>
-          <a:p>
-            <a:pPr marL="0" indent="0" algn="ctr">
-              <a:buNone/>
-            </a:pPr>
-            <a:r>
-              <a:rPr lang="en-US" sz="1800" dirty="0">
-                <a:solidFill>
-                  <a:srgbClr val="2A9D8F"/>
-                </a:solidFill>
-              </a:rPr>
-              <a:t>→</a:t>
-            </a:r>
-            <a:endParaRPr lang="en-US" sz="1800" dirty="0"/>
-          </a:p>
-        </p:txBody>
-      </p:sp>
-      <p:sp>
-        <p:nvSpPr>
-          <p:cNvPr id="33" name="Text 31"/>
-          <p:cNvSpPr/>
-          <p:nvPr/>
-        </p:nvSpPr>
-        <p:spPr>
-          <a:xfrm>
-            <a:off x="5120640" y="1508760"/>
-            <a:ext cx="274320" cy="365760"/>
-          </a:xfrm>
-          <a:prstGeom prst="rect">
-            <a:avLst/>
-          </a:prstGeom>
-          <a:noFill/>
-          <a:ln/>
-        </p:spPr>
-        <p:txBody>
-          <a:bodyPr wrap="square" rtlCol="0" anchor="ctr"/>
-          <a:lstStyle/>
-          <a:p>
-            <a:pPr marL="0" indent="0" algn="ctr">
-              <a:buNone/>
-            </a:pPr>
-            <a:r>
-              <a:rPr lang="en-US" sz="1800" dirty="0">
-                <a:solidFill>
-                  <a:srgbClr val="2A9D8F"/>
-                </a:solidFill>
-              </a:rPr>
-              <a:t>→</a:t>
-            </a:r>
-            <a:endParaRPr lang="en-US" sz="1800" dirty="0"/>
-          </a:p>
-        </p:txBody>
-      </p:sp>
-      <p:sp>
-        <p:nvSpPr>
-          <p:cNvPr id="34" name="Text 32"/>
-          <p:cNvSpPr/>
-          <p:nvPr/>
-        </p:nvSpPr>
-        <p:spPr>
-          <a:xfrm>
-            <a:off x="6812280" y="1508760"/>
-            <a:ext cx="274320" cy="365760"/>
-          </a:xfrm>
-          <a:prstGeom prst="rect">
-            <a:avLst/>
-          </a:prstGeom>
-          <a:noFill/>
-          <a:ln/>
-        </p:spPr>
-        <p:txBody>
-          <a:bodyPr wrap="square" rtlCol="0" anchor="ctr"/>
-          <a:lstStyle/>
-          <a:p>
-            <a:pPr marL="0" indent="0" algn="ctr">
-              <a:buNone/>
-            </a:pPr>
-            <a:r>
-              <a:rPr lang="en-US" sz="1800" dirty="0">
-                <a:solidFill>
-                  <a:srgbClr val="2A9D8F"/>
-                </a:solidFill>
-              </a:rPr>
-              <a:t>→</a:t>
-            </a:r>
-            <a:endParaRPr lang="en-US" sz="1800" dirty="0"/>
-          </a:p>
-        </p:txBody>
-      </p:sp>
-      <p:sp>
-        <p:nvSpPr>
-          <p:cNvPr id="35" name="Shape 33"/>
-          <p:cNvSpPr/>
-          <p:nvPr/>
-        </p:nvSpPr>
-        <p:spPr>
-          <a:xfrm>
-            <a:off x="274320" y="3017520"/>
-            <a:ext cx="4114800" cy="1737360"/>
-          </a:xfrm>
-          <a:prstGeom prst="rect">
-            <a:avLst/>
-          </a:prstGeom>
-          <a:solidFill>
-            <a:srgbClr val="FFFFFF"/>
-          </a:solidFill>
-          <a:ln/>
-          <a:effectLst>
-            <a:outerShdw blurRad="50800" dist="25400" dir="8100000" algn="bl" rotWithShape="0">
-              <a:srgbClr val="000000">
-                <a:alpha val="10000"/>
-              </a:srgbClr>
-            </a:outerShdw>
-          </a:effectLst>
-        </p:spPr>
-        <p:txBody>
-          <a:bodyPr/>
-          <a:lstStyle/>
-          <a:p>
-            <a:endParaRPr/>
-          </a:p>
-        </p:txBody>
-      </p:sp>
-      <p:sp>
-        <p:nvSpPr>
-          <p:cNvPr id="36" name="Shape 34"/>
-          <p:cNvSpPr/>
-          <p:nvPr/>
-        </p:nvSpPr>
-        <p:spPr>
-          <a:xfrm>
-            <a:off x="274320" y="3017520"/>
-            <a:ext cx="54864" cy="1737360"/>
-          </a:xfrm>
-          <a:prstGeom prst="rect">
-            <a:avLst/>
-          </a:prstGeom>
-          <a:solidFill>
-            <a:srgbClr val="2A9D8F"/>
-          </a:solidFill>
-          <a:ln/>
-        </p:spPr>
-        <p:txBody>
-          <a:bodyPr/>
-          <a:lstStyle/>
-          <a:p>
-            <a:endParaRPr/>
-          </a:p>
-        </p:txBody>
-      </p:sp>
-      <p:sp>
-        <p:nvSpPr>
-          <p:cNvPr id="37" name="Text 35"/>
-          <p:cNvSpPr/>
-          <p:nvPr/>
-        </p:nvSpPr>
-        <p:spPr>
-          <a:xfrm>
-            <a:off x="457200" y="3063240"/>
-            <a:ext cx="3657600" cy="228600"/>
-          </a:xfrm>
-          <a:prstGeom prst="rect">
-            <a:avLst/>
-          </a:prstGeom>
-          <a:noFill/>
-          <a:ln/>
-        </p:spPr>
-        <p:txBody>
-          <a:bodyPr wrap="square" rtlCol="0" anchor="ctr"/>
-          <a:lstStyle/>
-          <a:p>
-            <a:pPr marL="0" indent="0">
-              <a:buNone/>
-            </a:pPr>
-            <a:r>
-              <a:rPr lang="en-US" sz="1100" b="1" dirty="0">
-                <a:solidFill>
-                  <a:srgbClr val="1B3A5C"/>
-                </a:solidFill>
-              </a:rPr>
-              <a:t>ETL Control Framework</a:t>
-            </a:r>
-            <a:endParaRPr lang="en-US" sz="1100" dirty="0"/>
-          </a:p>
-        </p:txBody>
-      </p:sp>
-      <p:sp>
-        <p:nvSpPr>
-          <p:cNvPr id="38" name="Text 36"/>
-          <p:cNvSpPr/>
-          <p:nvPr/>
-        </p:nvSpPr>
-        <p:spPr>
-          <a:xfrm>
-            <a:off x="457200" y="3337560"/>
-            <a:ext cx="3749040" cy="1280160"/>
-          </a:xfrm>
-          <a:prstGeom prst="rect">
-            <a:avLst/>
-          </a:prstGeom>
-          <a:noFill/>
-          <a:ln/>
-        </p:spPr>
-        <p:txBody>
-          <a:bodyPr wrap="square" rtlCol="0" anchor="ctr"/>
-          <a:lstStyle/>
-          <a:p>
-            <a:pPr marL="342900" indent="-342900">
-              <a:spcAft>
-                <a:spcPts val="400"/>
-              </a:spcAft>
-              <a:buSzPct val="100000"/>
-              <a:buChar char="•"/>
-            </a:pPr>
-            <a:r>
-              <a:rPr lang="en-US" sz="900" dirty="0">
-                <a:solidFill>
-                  <a:srgbClr val="1E293B"/>
-                </a:solidFill>
-              </a:rPr>
-              <a:t>ETL_Process — Entity registry &amp; load order</a:t>
-            </a:r>
-            <a:endParaRPr lang="en-US" sz="900" dirty="0"/>
-          </a:p>
-          <a:p>
-            <a:pPr marL="342900" indent="-342900">
-              <a:spcAft>
-                <a:spcPts val="400"/>
-              </a:spcAft>
-              <a:buSzPct val="100000"/>
-              <a:buChar char="•"/>
-            </a:pPr>
-            <a:r>
-              <a:rPr lang="en-US" sz="900" dirty="0">
-                <a:solidFill>
-                  <a:srgbClr val="1E293B"/>
-                </a:solidFill>
-              </a:rPr>
-              <a:t>ETL_BatchLog / StepLog — Execution tracking</a:t>
-            </a:r>
-            <a:endParaRPr lang="en-US" sz="900" dirty="0"/>
-          </a:p>
-          <a:p>
-            <a:pPr marL="342900" indent="-342900">
-              <a:spcAft>
-                <a:spcPts val="400"/>
-              </a:spcAft>
-              <a:buSzPct val="100000"/>
-              <a:buChar char="•"/>
-            </a:pPr>
-            <a:r>
-              <a:rPr lang="en-US" sz="900" dirty="0">
-                <a:solidFill>
-                  <a:srgbClr val="1E293B"/>
-                </a:solidFill>
-              </a:rPr>
-              <a:t>ETL_Watermark — High-water mark per table</a:t>
-            </a:r>
-            <a:endParaRPr lang="en-US" sz="900" dirty="0"/>
-          </a:p>
-          <a:p>
-            <a:pPr marL="342900" indent="-342900">
-              <a:spcAft>
-                <a:spcPts val="400"/>
-              </a:spcAft>
-              <a:buSzPct val="100000"/>
-              <a:buChar char="•"/>
-            </a:pPr>
-            <a:r>
-              <a:rPr lang="en-US" sz="900" dirty="0">
-                <a:solidFill>
-                  <a:srgbClr val="1E293B"/>
-                </a:solidFill>
-              </a:rPr>
-              <a:t>ETL_ErrorLog — Error capture &amp; diagnostics</a:t>
-            </a:r>
-            <a:endParaRPr lang="en-US" sz="900" dirty="0"/>
-          </a:p>
-          <a:p>
-            <a:pPr marL="342900" indent="-342900">
-              <a:spcAft>
-                <a:spcPts val="400"/>
-              </a:spcAft>
-              <a:buSzPct val="100000"/>
-              <a:buChar char="•"/>
-            </a:pPr>
-            <a:r>
-              <a:rPr lang="en-US" sz="900" b="1" dirty="0">
-                <a:solidFill>
-                  <a:srgbClr val="2A9D8F"/>
-                </a:solidFill>
-              </a:rPr>
-              <a:t>Master: Master_Complete_Pipeline.dtsx</a:t>
-            </a:r>
-            <a:endParaRPr lang="en-US" sz="900" dirty="0"/>
-          </a:p>
-        </p:txBody>
-      </p:sp>
-      <p:sp>
-        <p:nvSpPr>
-          <p:cNvPr id="39" name="Shape 37"/>
-          <p:cNvSpPr/>
-          <p:nvPr/>
-        </p:nvSpPr>
-        <p:spPr>
-          <a:xfrm>
-            <a:off x="4754880" y="3017520"/>
-            <a:ext cx="4114800" cy="1737360"/>
-          </a:xfrm>
-          <a:prstGeom prst="rect">
-            <a:avLst/>
-          </a:prstGeom>
-          <a:solidFill>
-            <a:srgbClr val="FFFFFF"/>
-          </a:solidFill>
-          <a:ln/>
-          <a:effectLst>
-            <a:outerShdw blurRad="50800" dist="25400" dir="8100000" algn="bl" rotWithShape="0">
-              <a:srgbClr val="000000">
-                <a:alpha val="10000"/>
-              </a:srgbClr>
-            </a:outerShdw>
-          </a:effectLst>
-        </p:spPr>
-        <p:txBody>
-          <a:bodyPr/>
-          <a:lstStyle/>
-          <a:p>
-            <a:endParaRPr/>
-          </a:p>
-        </p:txBody>
-      </p:sp>
-      <p:sp>
-        <p:nvSpPr>
-          <p:cNvPr id="40" name="Shape 38"/>
-          <p:cNvSpPr/>
-          <p:nvPr/>
-        </p:nvSpPr>
-        <p:spPr>
-          <a:xfrm>
-            <a:off x="4754880" y="3017520"/>
-            <a:ext cx="54864" cy="1737360"/>
-          </a:xfrm>
-          <a:prstGeom prst="rect">
-            <a:avLst/>
-          </a:prstGeom>
-          <a:solidFill>
-            <a:srgbClr val="1B3A5C"/>
-          </a:solidFill>
-          <a:ln/>
-        </p:spPr>
-        <p:txBody>
-          <a:bodyPr/>
-          <a:lstStyle/>
-          <a:p>
-            <a:endParaRPr/>
-          </a:p>
-        </p:txBody>
-      </p:sp>
-      <p:sp>
-        <p:nvSpPr>
-          <p:cNvPr id="41" name="Text 39"/>
-          <p:cNvSpPr/>
-          <p:nvPr/>
-        </p:nvSpPr>
-        <p:spPr>
-          <a:xfrm>
-            <a:off x="4937760" y="3063240"/>
-            <a:ext cx="3657600" cy="228600"/>
-          </a:xfrm>
-          <a:prstGeom prst="rect">
-            <a:avLst/>
-          </a:prstGeom>
-          <a:noFill/>
-          <a:ln/>
-        </p:spPr>
-        <p:txBody>
-          <a:bodyPr wrap="square" rtlCol="0" anchor="ctr"/>
-          <a:lstStyle/>
-          <a:p>
-            <a:pPr marL="0" indent="0">
-              <a:buNone/>
-            </a:pPr>
-            <a:r>
-              <a:rPr lang="en-US" sz="1100" b="1" dirty="0">
-                <a:solidFill>
-                  <a:srgbClr val="1B3A5C"/>
-                </a:solidFill>
-              </a:rPr>
-              <a:t>Technology Stack</a:t>
-            </a:r>
-            <a:endParaRPr lang="en-US" sz="1100" dirty="0"/>
-          </a:p>
-        </p:txBody>
-      </p:sp>
-      <p:sp>
-        <p:nvSpPr>
-          <p:cNvPr id="42" name="Text 40"/>
-          <p:cNvSpPr/>
-          <p:nvPr/>
-        </p:nvSpPr>
-        <p:spPr>
-          <a:xfrm>
-            <a:off x="4937760" y="3337560"/>
-            <a:ext cx="3749040" cy="1280160"/>
-          </a:xfrm>
-          <a:prstGeom prst="rect">
-            <a:avLst/>
-          </a:prstGeom>
-          <a:noFill/>
-          <a:ln/>
-        </p:spPr>
-        <p:txBody>
-          <a:bodyPr wrap="square" rtlCol="0" anchor="ctr"/>
-          <a:lstStyle/>
-          <a:p>
-            <a:pPr marL="342900" indent="-342900">
-              <a:spcAft>
-                <a:spcPts val="400"/>
-              </a:spcAft>
-              <a:buSzPct val="100000"/>
-              <a:buChar char="•"/>
-            </a:pPr>
-            <a:r>
-              <a:rPr lang="en-US" sz="900" dirty="0">
-                <a:solidFill>
-                  <a:srgbClr val="1E293B"/>
-                </a:solidFill>
-              </a:rPr>
-              <a:t>SQL Server 2025 Developer Edition (v17)</a:t>
-            </a:r>
-            <a:endParaRPr lang="en-US" sz="900" dirty="0"/>
-          </a:p>
-          <a:p>
-            <a:pPr marL="342900" indent="-342900">
-              <a:spcAft>
-                <a:spcPts val="400"/>
-              </a:spcAft>
-              <a:buSzPct val="100000"/>
-              <a:buChar char="•"/>
-            </a:pPr>
-            <a:r>
-              <a:rPr lang="en-US" sz="900" dirty="0">
-                <a:solidFill>
-                  <a:srgbClr val="1E293B"/>
-                </a:solidFill>
-              </a:rPr>
-              <a:t>SSIS 2022+ — Project Deployment on SSISDB</a:t>
-            </a:r>
-            <a:endParaRPr lang="en-US" sz="900" dirty="0"/>
-          </a:p>
-          <a:p>
-            <a:pPr marL="342900" indent="-342900">
-              <a:spcAft>
-                <a:spcPts val="400"/>
-              </a:spcAft>
-              <a:buSzPct val="100000"/>
-              <a:buChar char="•"/>
-            </a:pPr>
-            <a:r>
-              <a:rPr lang="en-US" sz="900" dirty="0">
-                <a:solidFill>
-                  <a:srgbClr val="1E293B"/>
-                </a:solidFill>
-              </a:rPr>
-              <a:t>SHA-256 via HASHBYTES → VARBINARY(32)</a:t>
-            </a:r>
-            <a:endParaRPr lang="en-US" sz="900" dirty="0"/>
-          </a:p>
-          <a:p>
-            <a:pPr marL="342900" indent="-342900">
-              <a:spcAft>
-                <a:spcPts val="400"/>
-              </a:spcAft>
-              <a:buSzPct val="100000"/>
-              <a:buChar char="•"/>
-            </a:pPr>
-            <a:r>
-              <a:rPr lang="en-US" sz="900" dirty="0">
-                <a:solidFill>
-                  <a:srgbClr val="1E293B"/>
-                </a:solidFill>
-              </a:rPr>
-              <a:t>GCP e2-standard-4 (4 vCPU, 16GB, 128GB SSD)</a:t>
-            </a:r>
-            <a:endParaRPr lang="en-US" sz="900" dirty="0"/>
-          </a:p>
-          <a:p>
-            <a:pPr marL="342900" indent="-342900">
-              <a:spcAft>
-                <a:spcPts val="400"/>
-              </a:spcAft>
-              <a:buSzPct val="100000"/>
-              <a:buChar char="•"/>
-            </a:pPr>
-            <a:r>
-              <a:rPr lang="en-US" sz="900" b="1" dirty="0">
-                <a:solidFill>
-                  <a:srgbClr val="2A9D8F"/>
-                </a:solidFill>
-              </a:rPr>
-              <a:t>67 objects • 60 SSIS packages • 49 ETL steps</a:t>
+              <a:t>Data Warehouse Model — Data Vault 2.0 Methodology using Medallion Architecture</a:t>
             </a:r>
             <a:endParaRPr lang="en-US" sz="900" dirty="0"/>
           </a:p>

</xml_diff>